<commit_message>
fix: notification timer, sheet under status bar, raw note markers, wizard button [FR-REC-10, FR-BMK-02, NFR-09]
Found while capturing the quick guide on an Android phone emulator:
- The recording notification counted from a wrong base (498110:29:20):
  setWhen takes wall-clock time, not elapsedRealtime.
- The activity details and start activity sheets sat under the status bar;
  both now use the safe area.
- Notes showed **[Quick thought]**; bold is now rendered and app labels lose
  their brackets. Stored and exported text is unchanged.
- The welcome screen stacks its two secondary buttons on narrow screens.

Guide screenshots for step 1 and the activity details are retaken, and the
guide now names Windows as a download.

Co-Authored-By: Claude Opus 5.5 <noreply@anthropic.com>
</commit_message>
<xml_diff>
--- a/docs/user-guide/Attenlume-Quick-Guide.pptx
+++ b/docs/user-guide/Attenlume-Quick-Guide.pptx
@@ -124,20 +124,20 @@
   <p:extLst>
     <p:ext uri="{521415D9-36F7-43E2-AB2F-B90AF26B5E84}">
       <p14:sectionLst xmlns:p14="http://schemas.microsoft.com/office/powerpoint/2010/main">
-        <p14:section name="Welcome" id="{baade9ba-3ad9-88ff-c3ac-bc8fbd45ccd5}">
+        <p14:section name="Welcome" id="{f76050cf-6beb-cef7-2ede-b7aeb59d02c1}">
           <p14:sldIdLst>
             <p14:sldId id="256"/>
             <p14:sldId id="257"/>
           </p14:sldIdLst>
         </p14:section>
-        <p14:section name="Set up" id="{2e80045c-831c-a5f8-14f5-736fada8e7c7}">
+        <p14:section name="Set up" id="{a89ca391-1097-9826-3d08-49c31b7d8803}">
           <p14:sldIdLst>
             <p14:sldId id="258"/>
             <p14:sldId id="259"/>
             <p14:sldId id="260"/>
           </p14:sldIdLst>
         </p14:section>
-        <p14:section name="Capture" id="{d2e9d81b-4cd6-5538-a616-256a3b10b126}">
+        <p14:section name="Capture" id="{14762883-3337-c295-2d58-aec2438fe625}">
           <p14:sldIdLst>
             <p14:sldId id="261"/>
             <p14:sldId id="262"/>
@@ -145,21 +145,21 @@
             <p14:sldId id="264"/>
           </p14:sldIdLst>
         </p14:section>
-        <p14:section name="Review" id="{1b40da43-5b0c-2835-102b-62047cc40052}">
+        <p14:section name="Review" id="{796953d6-abf6-b7d2-37d8-31b1be376a23}">
           <p14:sldIdLst>
             <p14:sldId id="265"/>
             <p14:sldId id="266"/>
             <p14:sldId id="267"/>
           </p14:sldIdLst>
         </p14:section>
-        <p14:section name="Export and share" id="{fef876a9-607e-c004-1035-44ffcc42a130}">
+        <p14:section name="Export and share" id="{0978c7aa-8782-a61f-d35f-ea5f01b650d5}">
           <p14:sldIdLst>
             <p14:sldId id="268"/>
             <p14:sldId id="269"/>
             <p14:sldId id="270"/>
           </p14:sldIdLst>
         </p14:section>
-        <p14:section name="Privacy and tips" id="{25a00bbb-bd25-8d20-b064-1b0efa23b4b9}">
+        <p14:section name="Privacy and tips" id="{4b344fc2-2a16-56cc-9594-7a4c654f52a1}">
           <p14:sldIdLst>
             <p14:sldId id="271"/>
             <p14:sldId id="272"/>
@@ -2862,7 +2862,7 @@
                 <a:ea typeface="Montserrat" pitchFamily="34" charset="-122"/>
                 <a:cs typeface="Montserrat" pitchFamily="34" charset="-120"/>
               </a:rPr>
-              <a:t>For Android. Windows test build available.</a:t>
+              <a:t>For Android phones and tablets, and Windows.</a:t>
             </a:r>
             <a:endParaRPr lang="en-US" sz="1100" dirty="0"/>
           </a:p>
@@ -6171,7 +6171,7 @@
                 <a:ea typeface="Montserrat" pitchFamily="34" charset="-122"/>
                 <a:cs typeface="Montserrat" pitchFamily="34" charset="-120"/>
               </a:rPr>
-              <a:t>Download the latest Android version</a:t>
+              <a:t>Download for Android or Windows</a:t>
             </a:r>
             <a:endParaRPr lang="en-US" sz="1500" dirty="0"/>
           </a:p>

</xml_diff>

<commit_message>
docs(guide): quick guide for Copy AI prompt, Settings, Storage manager and import [FR-UI-09]
New screenshots from the phone emulator (Samlytics Conference 2026): export
result with Copy AI prompt, My conferences menu, Settings, Storage Manager and
Import an export. New section 5 'Settings and storage'. In-app text,
PowerPoint (22 slides) and PDF (9 pages) rebuilt from tool/guide.

Co-Authored-By: Claude Opus 5.5 <noreply@anthropic.com>
</commit_message>
<xml_diff>
--- a/docs/user-guide/Attenlume-Quick-Guide.pptx
+++ b/docs/user-guide/Attenlume-Quick-Guide.pptx
@@ -23,9 +23,13 @@
     <p:sldId id="271" r:id="rId17"/>
     <p:sldId id="272" r:id="rId18"/>
     <p:sldId id="273" r:id="rId19"/>
+    <p:sldId id="274" r:id="rId20"/>
+    <p:sldId id="275" r:id="rId21"/>
+    <p:sldId id="276" r:id="rId22"/>
+    <p:sldId id="277" r:id="rId23"/>
   </p:sldIdLst>
   <p:notesMasterIdLst>
-    <p:notesMasterId r:id="rId20"/>
+    <p:notesMasterId r:id="rId24"/>
   </p:notesMasterIdLst>
   <p:sldSz cx="9144000" cy="5143500"/>
   <p:notesSz cx="5143500" cy="9144000"/>
@@ -124,20 +128,20 @@
   <p:extLst>
     <p:ext uri="{521415D9-36F7-43E2-AB2F-B90AF26B5E84}">
       <p14:sectionLst xmlns:p14="http://schemas.microsoft.com/office/powerpoint/2010/main">
-        <p14:section name="Welcome" id="{f76050cf-6beb-cef7-2ede-b7aeb59d02c1}">
+        <p14:section name="Welcome" id="{9040d4ae-c569-953d-c116-ba2f363b1cd7}">
           <p14:sldIdLst>
             <p14:sldId id="256"/>
             <p14:sldId id="257"/>
           </p14:sldIdLst>
         </p14:section>
-        <p14:section name="Set up" id="{a89ca391-1097-9826-3d08-49c31b7d8803}">
+        <p14:section name="Set up" id="{fc189cd2-c087-9a39-d885-fbb0405cb25d}">
           <p14:sldIdLst>
             <p14:sldId id="258"/>
             <p14:sldId id="259"/>
             <p14:sldId id="260"/>
           </p14:sldIdLst>
         </p14:section>
-        <p14:section name="Capture" id="{14762883-3337-c295-2d58-aec2438fe625}">
+        <p14:section name="Capture" id="{f7da14c1-628a-7c89-81e2-53804dceb1ac}">
           <p14:sldIdLst>
             <p14:sldId id="261"/>
             <p14:sldId id="262"/>
@@ -145,25 +149,33 @@
             <p14:sldId id="264"/>
           </p14:sldIdLst>
         </p14:section>
-        <p14:section name="Review" id="{796953d6-abf6-b7d2-37d8-31b1be376a23}">
+        <p14:section name="Review" id="{f1b7867d-c866-0e9e-fdbf-15ed796f436b}">
           <p14:sldIdLst>
             <p14:sldId id="265"/>
             <p14:sldId id="266"/>
             <p14:sldId id="267"/>
           </p14:sldIdLst>
         </p14:section>
-        <p14:section name="Export and share" id="{0978c7aa-8782-a61f-d35f-ea5f01b650d5}">
+        <p14:section name="Export and share" id="{225b8c21-0cdb-0436-e4e6-78d3c0b6d355}">
           <p14:sldIdLst>
             <p14:sldId id="268"/>
             <p14:sldId id="269"/>
             <p14:sldId id="270"/>
           </p14:sldIdLst>
         </p14:section>
-        <p14:section name="Privacy and tips" id="{4b344fc2-2a16-56cc-9594-7a4c654f52a1}">
+        <p14:section name="Settings and storage" id="{5d8ca69c-9b3a-5231-b711-2116783199ca}">
           <p14:sldIdLst>
             <p14:sldId id="271"/>
             <p14:sldId id="272"/>
             <p14:sldId id="273"/>
+            <p14:sldId id="274"/>
+          </p14:sldIdLst>
+        </p14:section>
+        <p14:section name="Privacy and tips" id="{5e2d1063-5654-51f9-3585-4713a436adf2}">
+          <p14:sldIdLst>
+            <p14:sldId id="275"/>
+            <p14:sldId id="276"/>
+            <p14:sldId id="277"/>
           </p14:sldIdLst>
         </p14:section>
       </p14:sectionLst>
@@ -1404,6 +1416,94 @@
 </p:notes>
 </file>
 
+<file path=ppt/notesSlides/notesSlide19.xml><?xml version="1.0" encoding="utf-8"?>
+<p:notes xmlns:a="http://schemas.openxmlformats.org/drawingml/2006/main" xmlns:r="http://schemas.openxmlformats.org/officeDocument/2006/relationships" xmlns:p="http://schemas.openxmlformats.org/presentationml/2006/main">
+  <p:cSld>
+    <p:spTree>
+      <p:nvGrpSpPr>
+        <p:cNvPr id="1" name=""/>
+        <p:cNvGrpSpPr/>
+        <p:nvPr/>
+      </p:nvGrpSpPr>
+      <p:grpSpPr>
+        <a:xfrm>
+          <a:off x="0" y="0"/>
+          <a:ext cx="0" cy="0"/>
+          <a:chOff x="0" y="0"/>
+          <a:chExt cx="0" cy="0"/>
+        </a:xfrm>
+      </p:grpSpPr>
+      <p:sp>
+        <p:nvSpPr>
+          <p:cNvPr id="2" name="Slide Image Placeholder 1"/>
+          <p:cNvSpPr>
+            <a:spLocks noGrp="1" noRot="1" noChangeAspect="1"/>
+          </p:cNvSpPr>
+          <p:nvPr>
+            <p:ph type="sldImg"/>
+          </p:nvPr>
+        </p:nvSpPr>
+        <p:spPr/>
+      </p:sp>
+      <p:sp>
+        <p:nvSpPr>
+          <p:cNvPr id="3" name="Notes Placeholder 2"/>
+          <p:cNvSpPr>
+            <a:spLocks noGrp="1"/>
+          </p:cNvSpPr>
+          <p:nvPr>
+            <p:ph type="body" idx="1"/>
+          </p:nvPr>
+        </p:nvSpPr>
+        <p:spPr/>
+        <p:txBody>
+          <a:bodyPr/>
+          <a:lstStyle/>
+          <a:p>
+            <a:r>
+              <a:rPr lang="en-US" dirty="0"/>
+              <a:t/>
+            </a:r>
+            <a:endParaRPr lang="en-US" dirty="0"/>
+          </a:p>
+        </p:txBody>
+      </p:sp>
+      <p:sp>
+        <p:nvSpPr>
+          <p:cNvPr id="4" name="Slide Number Placeholder 3"/>
+          <p:cNvSpPr>
+            <a:spLocks noGrp="1"/>
+          </p:cNvSpPr>
+          <p:nvPr>
+            <p:ph type="sldNum" sz="quarter" idx="10"/>
+          </p:nvPr>
+        </p:nvSpPr>
+        <p:spPr/>
+        <p:txBody>
+          <a:bodyPr/>
+          <a:lstStyle/>
+          <a:p>
+            <a:fld id="{F7021451-1387-4CA6-816F-3879F97B5CBC}" type="slidenum">
+              <a:rPr lang="en-US"/>
+              <a:t>19</a:t>
+            </a:fld>
+            <a:endParaRPr lang="en-US"/>
+          </a:p>
+        </p:txBody>
+      </p:sp>
+    </p:spTree>
+    <p:extLst>
+      <p:ext uri="{BB962C8B-B14F-4D97-AF65-F5344CB8AC3E}">
+        <p14:creationId xmlns:p14="http://schemas.microsoft.com/office/powerpoint/2010/main" val="1024086991"/>
+      </p:ext>
+    </p:extLst>
+  </p:cSld>
+  <p:clrMapOvr>
+    <a:masterClrMapping/>
+  </p:clrMapOvr>
+</p:notes>
+</file>
+
 <file path=ppt/notesSlides/notesSlide2.xml><?xml version="1.0" encoding="utf-8"?>
 <p:notes xmlns:a="http://schemas.openxmlformats.org/drawingml/2006/main" xmlns:r="http://schemas.openxmlformats.org/officeDocument/2006/relationships" xmlns:p="http://schemas.openxmlformats.org/presentationml/2006/main">
   <p:cSld>
@@ -1474,6 +1574,270 @@
             <a:fld id="{F7021451-1387-4CA6-816F-3879F97B5CBC}" type="slidenum">
               <a:rPr lang="en-US"/>
               <a:t>2</a:t>
+            </a:fld>
+            <a:endParaRPr lang="en-US"/>
+          </a:p>
+        </p:txBody>
+      </p:sp>
+    </p:spTree>
+    <p:extLst>
+      <p:ext uri="{BB962C8B-B14F-4D97-AF65-F5344CB8AC3E}">
+        <p14:creationId xmlns:p14="http://schemas.microsoft.com/office/powerpoint/2010/main" val="1024086991"/>
+      </p:ext>
+    </p:extLst>
+  </p:cSld>
+  <p:clrMapOvr>
+    <a:masterClrMapping/>
+  </p:clrMapOvr>
+</p:notes>
+</file>
+
+<file path=ppt/notesSlides/notesSlide20.xml><?xml version="1.0" encoding="utf-8"?>
+<p:notes xmlns:a="http://schemas.openxmlformats.org/drawingml/2006/main" xmlns:r="http://schemas.openxmlformats.org/officeDocument/2006/relationships" xmlns:p="http://schemas.openxmlformats.org/presentationml/2006/main">
+  <p:cSld>
+    <p:spTree>
+      <p:nvGrpSpPr>
+        <p:cNvPr id="1" name=""/>
+        <p:cNvGrpSpPr/>
+        <p:nvPr/>
+      </p:nvGrpSpPr>
+      <p:grpSpPr>
+        <a:xfrm>
+          <a:off x="0" y="0"/>
+          <a:ext cx="0" cy="0"/>
+          <a:chOff x="0" y="0"/>
+          <a:chExt cx="0" cy="0"/>
+        </a:xfrm>
+      </p:grpSpPr>
+      <p:sp>
+        <p:nvSpPr>
+          <p:cNvPr id="2" name="Slide Image Placeholder 1"/>
+          <p:cNvSpPr>
+            <a:spLocks noGrp="1" noRot="1" noChangeAspect="1"/>
+          </p:cNvSpPr>
+          <p:nvPr>
+            <p:ph type="sldImg"/>
+          </p:nvPr>
+        </p:nvSpPr>
+        <p:spPr/>
+      </p:sp>
+      <p:sp>
+        <p:nvSpPr>
+          <p:cNvPr id="3" name="Notes Placeholder 2"/>
+          <p:cNvSpPr>
+            <a:spLocks noGrp="1"/>
+          </p:cNvSpPr>
+          <p:nvPr>
+            <p:ph type="body" idx="1"/>
+          </p:nvPr>
+        </p:nvSpPr>
+        <p:spPr/>
+        <p:txBody>
+          <a:bodyPr/>
+          <a:lstStyle/>
+          <a:p>
+            <a:r>
+              <a:rPr lang="en-US" dirty="0"/>
+              <a:t/>
+            </a:r>
+            <a:endParaRPr lang="en-US" dirty="0"/>
+          </a:p>
+        </p:txBody>
+      </p:sp>
+      <p:sp>
+        <p:nvSpPr>
+          <p:cNvPr id="4" name="Slide Number Placeholder 3"/>
+          <p:cNvSpPr>
+            <a:spLocks noGrp="1"/>
+          </p:cNvSpPr>
+          <p:nvPr>
+            <p:ph type="sldNum" sz="quarter" idx="10"/>
+          </p:nvPr>
+        </p:nvSpPr>
+        <p:spPr/>
+        <p:txBody>
+          <a:bodyPr/>
+          <a:lstStyle/>
+          <a:p>
+            <a:fld id="{F7021451-1387-4CA6-816F-3879F97B5CBC}" type="slidenum">
+              <a:rPr lang="en-US"/>
+              <a:t>20</a:t>
+            </a:fld>
+            <a:endParaRPr lang="en-US"/>
+          </a:p>
+        </p:txBody>
+      </p:sp>
+    </p:spTree>
+    <p:extLst>
+      <p:ext uri="{BB962C8B-B14F-4D97-AF65-F5344CB8AC3E}">
+        <p14:creationId xmlns:p14="http://schemas.microsoft.com/office/powerpoint/2010/main" val="1024086991"/>
+      </p:ext>
+    </p:extLst>
+  </p:cSld>
+  <p:clrMapOvr>
+    <a:masterClrMapping/>
+  </p:clrMapOvr>
+</p:notes>
+</file>
+
+<file path=ppt/notesSlides/notesSlide21.xml><?xml version="1.0" encoding="utf-8"?>
+<p:notes xmlns:a="http://schemas.openxmlformats.org/drawingml/2006/main" xmlns:r="http://schemas.openxmlformats.org/officeDocument/2006/relationships" xmlns:p="http://schemas.openxmlformats.org/presentationml/2006/main">
+  <p:cSld>
+    <p:spTree>
+      <p:nvGrpSpPr>
+        <p:cNvPr id="1" name=""/>
+        <p:cNvGrpSpPr/>
+        <p:nvPr/>
+      </p:nvGrpSpPr>
+      <p:grpSpPr>
+        <a:xfrm>
+          <a:off x="0" y="0"/>
+          <a:ext cx="0" cy="0"/>
+          <a:chOff x="0" y="0"/>
+          <a:chExt cx="0" cy="0"/>
+        </a:xfrm>
+      </p:grpSpPr>
+      <p:sp>
+        <p:nvSpPr>
+          <p:cNvPr id="2" name="Slide Image Placeholder 1"/>
+          <p:cNvSpPr>
+            <a:spLocks noGrp="1" noRot="1" noChangeAspect="1"/>
+          </p:cNvSpPr>
+          <p:nvPr>
+            <p:ph type="sldImg"/>
+          </p:nvPr>
+        </p:nvSpPr>
+        <p:spPr/>
+      </p:sp>
+      <p:sp>
+        <p:nvSpPr>
+          <p:cNvPr id="3" name="Notes Placeholder 2"/>
+          <p:cNvSpPr>
+            <a:spLocks noGrp="1"/>
+          </p:cNvSpPr>
+          <p:nvPr>
+            <p:ph type="body" idx="1"/>
+          </p:nvPr>
+        </p:nvSpPr>
+        <p:spPr/>
+        <p:txBody>
+          <a:bodyPr/>
+          <a:lstStyle/>
+          <a:p>
+            <a:r>
+              <a:rPr lang="en-US" dirty="0"/>
+              <a:t/>
+            </a:r>
+            <a:endParaRPr lang="en-US" dirty="0"/>
+          </a:p>
+        </p:txBody>
+      </p:sp>
+      <p:sp>
+        <p:nvSpPr>
+          <p:cNvPr id="4" name="Slide Number Placeholder 3"/>
+          <p:cNvSpPr>
+            <a:spLocks noGrp="1"/>
+          </p:cNvSpPr>
+          <p:nvPr>
+            <p:ph type="sldNum" sz="quarter" idx="10"/>
+          </p:nvPr>
+        </p:nvSpPr>
+        <p:spPr/>
+        <p:txBody>
+          <a:bodyPr/>
+          <a:lstStyle/>
+          <a:p>
+            <a:fld id="{F7021451-1387-4CA6-816F-3879F97B5CBC}" type="slidenum">
+              <a:rPr lang="en-US"/>
+              <a:t>21</a:t>
+            </a:fld>
+            <a:endParaRPr lang="en-US"/>
+          </a:p>
+        </p:txBody>
+      </p:sp>
+    </p:spTree>
+    <p:extLst>
+      <p:ext uri="{BB962C8B-B14F-4D97-AF65-F5344CB8AC3E}">
+        <p14:creationId xmlns:p14="http://schemas.microsoft.com/office/powerpoint/2010/main" val="1024086991"/>
+      </p:ext>
+    </p:extLst>
+  </p:cSld>
+  <p:clrMapOvr>
+    <a:masterClrMapping/>
+  </p:clrMapOvr>
+</p:notes>
+</file>
+
+<file path=ppt/notesSlides/notesSlide22.xml><?xml version="1.0" encoding="utf-8"?>
+<p:notes xmlns:a="http://schemas.openxmlformats.org/drawingml/2006/main" xmlns:r="http://schemas.openxmlformats.org/officeDocument/2006/relationships" xmlns:p="http://schemas.openxmlformats.org/presentationml/2006/main">
+  <p:cSld>
+    <p:spTree>
+      <p:nvGrpSpPr>
+        <p:cNvPr id="1" name=""/>
+        <p:cNvGrpSpPr/>
+        <p:nvPr/>
+      </p:nvGrpSpPr>
+      <p:grpSpPr>
+        <a:xfrm>
+          <a:off x="0" y="0"/>
+          <a:ext cx="0" cy="0"/>
+          <a:chOff x="0" y="0"/>
+          <a:chExt cx="0" cy="0"/>
+        </a:xfrm>
+      </p:grpSpPr>
+      <p:sp>
+        <p:nvSpPr>
+          <p:cNvPr id="2" name="Slide Image Placeholder 1"/>
+          <p:cNvSpPr>
+            <a:spLocks noGrp="1" noRot="1" noChangeAspect="1"/>
+          </p:cNvSpPr>
+          <p:nvPr>
+            <p:ph type="sldImg"/>
+          </p:nvPr>
+        </p:nvSpPr>
+        <p:spPr/>
+      </p:sp>
+      <p:sp>
+        <p:nvSpPr>
+          <p:cNvPr id="3" name="Notes Placeholder 2"/>
+          <p:cNvSpPr>
+            <a:spLocks noGrp="1"/>
+          </p:cNvSpPr>
+          <p:nvPr>
+            <p:ph type="body" idx="1"/>
+          </p:nvPr>
+        </p:nvSpPr>
+        <p:spPr/>
+        <p:txBody>
+          <a:bodyPr/>
+          <a:lstStyle/>
+          <a:p>
+            <a:r>
+              <a:rPr lang="en-US" dirty="0"/>
+              <a:t/>
+            </a:r>
+            <a:endParaRPr lang="en-US" dirty="0"/>
+          </a:p>
+        </p:txBody>
+      </p:sp>
+      <p:sp>
+        <p:nvSpPr>
+          <p:cNvPr id="4" name="Slide Number Placeholder 3"/>
+          <p:cNvSpPr>
+            <a:spLocks noGrp="1"/>
+          </p:cNvSpPr>
+          <p:nvPr>
+            <p:ph type="sldNum" sz="quarter" idx="10"/>
+          </p:nvPr>
+        </p:nvSpPr>
+        <p:spPr/>
+        <p:txBody>
+          <a:bodyPr/>
+          <a:lstStyle/>
+          <a:p>
+            <a:fld id="{F7021451-1387-4CA6-816F-3879F97B5CBC}" type="slidenum">
+              <a:rPr lang="en-US"/>
+              <a:t>22</a:t>
             </a:fld>
             <a:endParaRPr lang="en-US"/>
           </a:p>
@@ -3002,7 +3366,7 @@
         <p:spPr>
           <a:xfrm>
             <a:off x="685800" y="2240280"/>
-            <a:ext cx="4754880" cy="731520"/>
+            <a:ext cx="5669280" cy="731520"/>
           </a:xfrm>
           <a:prstGeom prst="rect">
             <a:avLst/>
@@ -3963,7 +4327,7 @@
         <p:spPr>
           <a:xfrm>
             <a:off x="685800" y="2240280"/>
-            <a:ext cx="4754880" cy="731520"/>
+            <a:ext cx="5669280" cy="731520"/>
           </a:xfrm>
           <a:prstGeom prst="rect">
             <a:avLst/>
@@ -4593,7 +4957,7 @@
                 <a:ea typeface="Montserrat" pitchFamily="34" charset="-122"/>
                 <a:cs typeface="Montserrat" pitchFamily="34" charset="-120"/>
               </a:rPr>
-              <a:t>Save and share</a:t>
+              <a:t>Save, share and ask AI</a:t>
             </a:r>
             <a:endParaRPr lang="en-US" sz="2400" dirty="0"/>
           </a:p>
@@ -4636,7 +5000,7 @@
                 <a:ea typeface="Montserrat" pitchFamily="34" charset="-122"/>
                 <a:cs typeface="Montserrat" pitchFamily="34" charset="-120"/>
               </a:rPr>
-              <a:t>When the export is saved, tap Share.</a:t>
+              <a:t>When the export is saved, tap Share to send the ZIP to Google Drive, Gmail, Files or an AI app.</a:t>
             </a:r>
             <a:endParaRPr lang="en-US" sz="1400" dirty="0"/>
           </a:p>
@@ -4657,7 +5021,7 @@
                 <a:ea typeface="Montserrat" pitchFamily="34" charset="-122"/>
                 <a:cs typeface="Montserrat" pitchFamily="34" charset="-120"/>
               </a:rPr>
-              <a:t>Send the ZIP to Google Drive, Gmail, Files or an AI app.</a:t>
+              <a:t>Tap Copy AI prompt, then paste it into ChatGPT, Claude or Gemini with the exported files. It already holds your role, goals and the outputs you want.</a:t>
             </a:r>
             <a:endParaRPr lang="en-US" sz="1400" dirty="0"/>
           </a:p>
@@ -4678,7 +5042,7 @@
                 <a:ea typeface="Montserrat" pitchFamily="34" charset="-122"/>
                 <a:cs typeface="Montserrat" pitchFamily="34" charset="-120"/>
               </a:rPr>
-              <a:t>A copy stays in Attenlume. Checksums inside the ZIP let you confirm nothing changed.</a:t>
+              <a:t>Inside the export, README_START_HERE explains every file, and timeline.csv lists each bookmark and photo with the exact place in the recording.</a:t>
             </a:r>
             <a:endParaRPr lang="en-US" sz="1400" dirty="0"/>
           </a:p>
@@ -4859,6 +5223,13 @@
 <file path=ppt/slides/slide16.xml><?xml version="1.0" encoding="utf-8"?>
 <p:sld xmlns:a="http://schemas.openxmlformats.org/drawingml/2006/main" xmlns:r="http://schemas.openxmlformats.org/officeDocument/2006/relationships" xmlns:p="http://schemas.openxmlformats.org/presentationml/2006/main">
   <p:cSld name="Slide 16">
+    <p:bg>
+      <p:bgPr>
+        <a:solidFill>
+          <a:srgbClr val="00212B"/>
+        </a:solidFill>
+      </p:bgPr>
+    </p:bg>
     <p:spTree>
       <p:nvGrpSpPr>
         <p:cNvPr id="1" name=""/>
@@ -4875,56 +5246,19 @@
       </p:grpSpPr>
       <p:sp>
         <p:nvSpPr>
-          <p:cNvPr id="2" name="Text 0"/>
-          <p:cNvSpPr txBox="1"/>
-          <p:nvPr/>
-        </p:nvSpPr>
-        <p:spPr>
-          <a:xfrm>
-            <a:off x="457200" y="411480"/>
-            <a:ext cx="4754880" cy="640080"/>
-          </a:xfrm>
-          <a:prstGeom prst="rect">
-            <a:avLst/>
-          </a:prstGeom>
-          <a:noFill/>
-          <a:ln/>
-        </p:spPr>
-        <p:txBody>
-          <a:bodyPr wrap="square" lIns="0" tIns="0" rIns="0" bIns="0" rtlCol="0" anchor="ctr"/>
-          <a:lstStyle/>
-          <a:p>
-            <a:pPr indent="0" marL="0">
-              <a:buNone/>
-            </a:pPr>
-            <a:r>
-              <a:rPr lang="en-US" sz="3000" b="1" dirty="0">
-                <a:solidFill>
-                  <a:srgbClr val="4392F1"/>
-                </a:solidFill>
-                <a:latin typeface="Montserrat" pitchFamily="34" charset="0"/>
-                <a:ea typeface="Montserrat" pitchFamily="34" charset="-122"/>
-                <a:cs typeface="Montserrat" pitchFamily="34" charset="-120"/>
-              </a:rPr>
-              <a:t>Your privacy</a:t>
-            </a:r>
-            <a:endParaRPr lang="en-US" sz="3000" dirty="0"/>
-          </a:p>
-        </p:txBody>
-      </p:sp>
-      <p:sp>
-        <p:nvSpPr>
-          <p:cNvPr id="3" name="Shape 1"/>
+          <p:cNvPr id="2" name="Shape 0"/>
           <p:cNvSpPr/>
           <p:nvPr/>
         </p:nvSpPr>
         <p:spPr>
-          <a:xfrm>
-            <a:off x="457200" y="1280160"/>
-            <a:ext cx="329184" cy="329184"/>
-          </a:xfrm>
-          <a:prstGeom prst="ellipse">
-            <a:avLst/>
+          <a:xfrm rot="1800000">
+            <a:off x="-548640" y="4480560"/>
+            <a:ext cx="2194560" cy="502920"/>
+          </a:xfrm>
+          <a:prstGeom prst="roundRect">
+            <a:avLst>
+              <a:gd name="adj" fmla="val 49091"/>
+            </a:avLst>
           </a:prstGeom>
           <a:solidFill>
             <a:srgbClr val="DCFF38"/>
@@ -4939,102 +5273,26 @@
       </p:sp>
       <p:sp>
         <p:nvSpPr>
-          <p:cNvPr id="4" name="Text 2"/>
-          <p:cNvSpPr txBox="1"/>
-          <p:nvPr/>
-        </p:nvSpPr>
-        <p:spPr>
-          <a:xfrm>
-            <a:off x="457200" y="1280160"/>
-            <a:ext cx="329184" cy="329184"/>
-          </a:xfrm>
-          <a:prstGeom prst="rect">
-            <a:avLst/>
-          </a:prstGeom>
-          <a:noFill/>
-          <a:ln/>
-        </p:spPr>
-        <p:txBody>
-          <a:bodyPr wrap="square" lIns="0" tIns="0" rIns="0" bIns="0" rtlCol="0" anchor="ctr"/>
-          <a:lstStyle/>
-          <a:p>
-            <a:pPr algn="ctr" indent="0" marL="0">
-              <a:buNone/>
-            </a:pPr>
-            <a:r>
-              <a:rPr lang="en-US" sz="1300" b="1" dirty="0">
-                <a:solidFill>
-                  <a:srgbClr val="00212B"/>
-                </a:solidFill>
-                <a:latin typeface="Montserrat" pitchFamily="34" charset="0"/>
-                <a:ea typeface="Montserrat" pitchFamily="34" charset="-122"/>
-                <a:cs typeface="Montserrat" pitchFamily="34" charset="-120"/>
-              </a:rPr>
-              <a:t>✓</a:t>
-            </a:r>
-            <a:endParaRPr lang="en-US" sz="1300" dirty="0"/>
-          </a:p>
-        </p:txBody>
-      </p:sp>
-      <p:sp>
-        <p:nvSpPr>
-          <p:cNvPr id="5" name="Text 3"/>
-          <p:cNvSpPr txBox="1"/>
-          <p:nvPr/>
-        </p:nvSpPr>
-        <p:spPr>
-          <a:xfrm>
-            <a:off x="960120" y="1234440"/>
-            <a:ext cx="4297680" cy="731520"/>
-          </a:xfrm>
-          <a:prstGeom prst="rect">
-            <a:avLst/>
-          </a:prstGeom>
-          <a:noFill/>
-          <a:ln/>
-        </p:spPr>
-        <p:txBody>
-          <a:bodyPr wrap="square" lIns="0" tIns="0" rIns="0" bIns="0" rtlCol="0" anchor="t"/>
-          <a:lstStyle/>
-          <a:p>
-            <a:pPr indent="0" marL="0">
-              <a:buNone/>
-            </a:pPr>
-            <a:r>
-              <a:rPr lang="en-US" sz="1300" dirty="0">
-                <a:solidFill>
-                  <a:srgbClr val="00212B"/>
-                </a:solidFill>
-                <a:latin typeface="Montserrat" pitchFamily="34" charset="0"/>
-                <a:ea typeface="Montserrat" pitchFamily="34" charset="-122"/>
-                <a:cs typeface="Montserrat" pitchFamily="34" charset="-120"/>
-              </a:rPr>
-              <a:t>Your conferences, recordings, photos and notes stay on this device unless you export or share them.</a:t>
-            </a:r>
-            <a:endParaRPr lang="en-US" sz="1300" dirty="0"/>
-          </a:p>
-        </p:txBody>
-      </p:sp>
-      <p:sp>
-        <p:nvSpPr>
-          <p:cNvPr id="6" name="Shape 4"/>
+          <p:cNvPr id="3" name="Shape 1"/>
           <p:cNvSpPr/>
           <p:nvPr/>
         </p:nvSpPr>
         <p:spPr>
-          <a:xfrm>
-            <a:off x="457200" y="2103120"/>
-            <a:ext cx="329184" cy="329184"/>
-          </a:xfrm>
-          <a:prstGeom prst="ellipse">
-            <a:avLst/>
+          <a:xfrm rot="1800000">
+            <a:off x="7955280" y="-274320"/>
+            <a:ext cx="2194560" cy="548640"/>
+          </a:xfrm>
+          <a:prstGeom prst="roundRect">
+            <a:avLst>
+              <a:gd name="adj" fmla="val 50000"/>
+            </a:avLst>
           </a:prstGeom>
           <a:solidFill>
-            <a:srgbClr val="DCFF38"/>
+            <a:srgbClr val="4392F1"/>
           </a:solidFill>
           <a:ln w="12700">
             <a:solidFill>
-              <a:srgbClr val="DCFF38"/>
+              <a:srgbClr val="4392F1"/>
             </a:solidFill>
             <a:prstDash val="solid"/>
           </a:ln>
@@ -5042,14 +5300,14 @@
       </p:sp>
       <p:sp>
         <p:nvSpPr>
-          <p:cNvPr id="7" name="Text 5"/>
+          <p:cNvPr id="4" name="Text 2"/>
           <p:cNvSpPr txBox="1"/>
           <p:nvPr/>
         </p:nvSpPr>
         <p:spPr>
           <a:xfrm>
-            <a:off x="457200" y="2103120"/>
-            <a:ext cx="329184" cy="329184"/>
+            <a:off x="685800" y="1234440"/>
+            <a:ext cx="1371600" cy="1005840"/>
           </a:xfrm>
           <a:prstGeom prst="rect">
             <a:avLst/>
@@ -5061,34 +5319,34 @@
           <a:bodyPr wrap="square" lIns="0" tIns="0" rIns="0" bIns="0" rtlCol="0" anchor="ctr"/>
           <a:lstStyle/>
           <a:p>
-            <a:pPr algn="ctr" indent="0" marL="0">
+            <a:pPr indent="0" marL="0">
               <a:buNone/>
             </a:pPr>
             <a:r>
-              <a:rPr lang="en-US" sz="1300" b="1" dirty="0">
-                <a:solidFill>
-                  <a:srgbClr val="00212B"/>
-                </a:solidFill>
-                <a:latin typeface="Montserrat" pitchFamily="34" charset="0"/>
-                <a:ea typeface="Montserrat" pitchFamily="34" charset="-122"/>
-                <a:cs typeface="Montserrat" pitchFamily="34" charset="-120"/>
-              </a:rPr>
-              <a:t>✓</a:t>
-            </a:r>
-            <a:endParaRPr lang="en-US" sz="1300" dirty="0"/>
-          </a:p>
-        </p:txBody>
-      </p:sp>
-      <p:sp>
-        <p:nvSpPr>
-          <p:cNvPr id="8" name="Text 6"/>
+              <a:rPr lang="en-US" sz="6600" b="1" dirty="0">
+                <a:solidFill>
+                  <a:srgbClr val="DCFF38"/>
+                </a:solidFill>
+                <a:latin typeface="Montserrat" pitchFamily="34" charset="0"/>
+                <a:ea typeface="Montserrat" pitchFamily="34" charset="-122"/>
+                <a:cs typeface="Montserrat" pitchFamily="34" charset="-120"/>
+              </a:rPr>
+              <a:t>5</a:t>
+            </a:r>
+            <a:endParaRPr lang="en-US" sz="6600" dirty="0"/>
+          </a:p>
+        </p:txBody>
+      </p:sp>
+      <p:sp>
+        <p:nvSpPr>
+          <p:cNvPr id="5" name="Text 3"/>
           <p:cNvSpPr txBox="1"/>
           <p:nvPr/>
         </p:nvSpPr>
         <p:spPr>
           <a:xfrm>
-            <a:off x="960120" y="2057400"/>
-            <a:ext cx="4297680" cy="731520"/>
+            <a:off x="685800" y="2240280"/>
+            <a:ext cx="5669280" cy="731520"/>
           </a:xfrm>
           <a:prstGeom prst="rect">
             <a:avLst/>
@@ -5097,62 +5355,37 @@
           <a:ln/>
         </p:spPr>
         <p:txBody>
-          <a:bodyPr wrap="square" lIns="0" tIns="0" rIns="0" bIns="0" rtlCol="0" anchor="t"/>
+          <a:bodyPr wrap="square" lIns="0" tIns="0" rIns="0" bIns="0" rtlCol="0" anchor="ctr"/>
           <a:lstStyle/>
           <a:p>
             <a:pPr indent="0" marL="0">
               <a:buNone/>
             </a:pPr>
             <a:r>
-              <a:rPr lang="en-US" sz="1300" dirty="0">
-                <a:solidFill>
-                  <a:srgbClr val="00212B"/>
-                </a:solidFill>
-                <a:latin typeface="Montserrat" pitchFamily="34" charset="0"/>
-                <a:ea typeface="Montserrat" pitchFamily="34" charset="-122"/>
-                <a:cs typeface="Montserrat" pitchFamily="34" charset="-120"/>
-              </a:rPr>
-              <a:t>No account, no analytics, no adverts and no trackers.</a:t>
-            </a:r>
-            <a:endParaRPr lang="en-US" sz="1300" dirty="0"/>
-          </a:p>
-        </p:txBody>
-      </p:sp>
-      <p:sp>
-        <p:nvSpPr>
-          <p:cNvPr id="9" name="Shape 7"/>
-          <p:cNvSpPr/>
-          <p:nvPr/>
-        </p:nvSpPr>
-        <p:spPr>
-          <a:xfrm>
-            <a:off x="457200" y="2926080"/>
-            <a:ext cx="329184" cy="329184"/>
-          </a:xfrm>
-          <a:prstGeom prst="ellipse">
-            <a:avLst/>
-          </a:prstGeom>
-          <a:solidFill>
-            <a:srgbClr val="DCFF38"/>
-          </a:solidFill>
-          <a:ln w="12700">
-            <a:solidFill>
-              <a:srgbClr val="DCFF38"/>
-            </a:solidFill>
-            <a:prstDash val="solid"/>
-          </a:ln>
-        </p:spPr>
-      </p:sp>
-      <p:sp>
-        <p:nvSpPr>
-          <p:cNvPr id="10" name="Text 8"/>
+              <a:rPr lang="en-US" sz="3200" b="1" dirty="0">
+                <a:solidFill>
+                  <a:srgbClr val="FEFFF8"/>
+                </a:solidFill>
+                <a:latin typeface="Montserrat" pitchFamily="34" charset="0"/>
+                <a:ea typeface="Montserrat" pitchFamily="34" charset="-122"/>
+                <a:cs typeface="Montserrat" pitchFamily="34" charset="-120"/>
+              </a:rPr>
+              <a:t>Settings and storage</a:t>
+            </a:r>
+            <a:endParaRPr lang="en-US" sz="3200" dirty="0"/>
+          </a:p>
+        </p:txBody>
+      </p:sp>
+      <p:sp>
+        <p:nvSpPr>
+          <p:cNvPr id="6" name="Text 4"/>
           <p:cNvSpPr txBox="1"/>
           <p:nvPr/>
         </p:nvSpPr>
         <p:spPr>
           <a:xfrm>
-            <a:off x="457200" y="2926080"/>
-            <a:ext cx="329184" cy="329184"/>
+            <a:off x="685800" y="3017520"/>
+            <a:ext cx="4754880" cy="548640"/>
           </a:xfrm>
           <a:prstGeom prst="rect">
             <a:avLst/>
@@ -5164,180 +5397,38 @@
           <a:bodyPr wrap="square" lIns="0" tIns="0" rIns="0" bIns="0" rtlCol="0" anchor="ctr"/>
           <a:lstStyle/>
           <a:p>
-            <a:pPr algn="ctr" indent="0" marL="0">
-              <a:buNone/>
-            </a:pPr>
-            <a:r>
-              <a:rPr lang="en-US" sz="1300" b="1" dirty="0">
-                <a:solidFill>
-                  <a:srgbClr val="00212B"/>
-                </a:solidFill>
-                <a:latin typeface="Montserrat" pitchFamily="34" charset="0"/>
-                <a:ea typeface="Montserrat" pitchFamily="34" charset="-122"/>
-                <a:cs typeface="Montserrat" pitchFamily="34" charset="-120"/>
-              </a:rPr>
-              <a:t>✓</a:t>
-            </a:r>
-            <a:endParaRPr lang="en-US" sz="1300" dirty="0"/>
-          </a:p>
-        </p:txBody>
-      </p:sp>
-      <p:sp>
-        <p:nvSpPr>
-          <p:cNvPr id="11" name="Text 9"/>
-          <p:cNvSpPr txBox="1"/>
-          <p:nvPr/>
-        </p:nvSpPr>
-        <p:spPr>
-          <a:xfrm>
-            <a:off x="960120" y="2880360"/>
-            <a:ext cx="4297680" cy="731520"/>
-          </a:xfrm>
-          <a:prstGeom prst="rect">
-            <a:avLst/>
-          </a:prstGeom>
-          <a:noFill/>
-          <a:ln/>
-        </p:spPr>
-        <p:txBody>
-          <a:bodyPr wrap="square" lIns="0" tIns="0" rIns="0" bIns="0" rtlCol="0" anchor="t"/>
-          <a:lstStyle/>
-          <a:p>
             <a:pPr indent="0" marL="0">
               <a:buNone/>
             </a:pPr>
             <a:r>
-              <a:rPr lang="en-US" sz="1300" dirty="0">
-                <a:solidFill>
-                  <a:srgbClr val="00212B"/>
-                </a:solidFill>
-                <a:latin typeface="Montserrat" pitchFamily="34" charset="0"/>
-                <a:ea typeface="Montserrat" pitchFamily="34" charset="-122"/>
-                <a:cs typeface="Montserrat" pitchFamily="34" charset="-120"/>
-              </a:rPr>
-              <a:t>Recording is always shown on screen. There is no hidden recording mode.</a:t>
-            </a:r>
-            <a:endParaRPr lang="en-US" sz="1300" dirty="0"/>
-          </a:p>
-        </p:txBody>
-      </p:sp>
-      <p:sp>
-        <p:nvSpPr>
-          <p:cNvPr id="12" name="Shape 10"/>
+              <a:rPr lang="en-US" sz="1600" dirty="0">
+                <a:solidFill>
+                  <a:srgbClr val="4392F1"/>
+                </a:solidFill>
+                <a:latin typeface="Montserrat" pitchFamily="34" charset="0"/>
+                <a:ea typeface="Montserrat" pitchFamily="34" charset="-122"/>
+                <a:cs typeface="Montserrat" pitchFamily="34" charset="-120"/>
+              </a:rPr>
+              <a:t>Make Attenlume work your way, and keep your device tidy.</a:t>
+            </a:r>
+            <a:endParaRPr lang="en-US" sz="1600" dirty="0"/>
+          </a:p>
+        </p:txBody>
+      </p:sp>
+      <p:sp>
+        <p:nvSpPr>
+          <p:cNvPr id="7" name="Shape 5"/>
           <p:cNvSpPr/>
           <p:nvPr/>
         </p:nvSpPr>
         <p:spPr>
           <a:xfrm>
-            <a:off x="457200" y="3749040"/>
-            <a:ext cx="329184" cy="329184"/>
-          </a:xfrm>
-          <a:prstGeom prst="ellipse">
-            <a:avLst/>
-          </a:prstGeom>
-          <a:solidFill>
-            <a:srgbClr val="DCFF38"/>
-          </a:solidFill>
-          <a:ln w="12700">
-            <a:solidFill>
-              <a:srgbClr val="DCFF38"/>
-            </a:solidFill>
-            <a:prstDash val="solid"/>
-          </a:ln>
-        </p:spPr>
-      </p:sp>
-      <p:sp>
-        <p:nvSpPr>
-          <p:cNvPr id="13" name="Text 11"/>
-          <p:cNvSpPr txBox="1"/>
-          <p:nvPr/>
-        </p:nvSpPr>
-        <p:spPr>
-          <a:xfrm>
-            <a:off x="457200" y="3749040"/>
-            <a:ext cx="329184" cy="329184"/>
-          </a:xfrm>
-          <a:prstGeom prst="rect">
-            <a:avLst/>
-          </a:prstGeom>
-          <a:noFill/>
-          <a:ln/>
-        </p:spPr>
-        <p:txBody>
-          <a:bodyPr wrap="square" lIns="0" tIns="0" rIns="0" bIns="0" rtlCol="0" anchor="ctr"/>
-          <a:lstStyle/>
-          <a:p>
-            <a:pPr algn="ctr" indent="0" marL="0">
-              <a:buNone/>
-            </a:pPr>
-            <a:r>
-              <a:rPr lang="en-US" sz="1300" b="1" dirty="0">
-                <a:solidFill>
-                  <a:srgbClr val="00212B"/>
-                </a:solidFill>
-                <a:latin typeface="Montserrat" pitchFamily="34" charset="0"/>
-                <a:ea typeface="Montserrat" pitchFamily="34" charset="-122"/>
-                <a:cs typeface="Montserrat" pitchFamily="34" charset="-120"/>
-              </a:rPr>
-              <a:t>✓</a:t>
-            </a:r>
-            <a:endParaRPr lang="en-US" sz="1300" dirty="0"/>
-          </a:p>
-        </p:txBody>
-      </p:sp>
-      <p:sp>
-        <p:nvSpPr>
-          <p:cNvPr id="14" name="Text 12"/>
-          <p:cNvSpPr txBox="1"/>
-          <p:nvPr/>
-        </p:nvSpPr>
-        <p:spPr>
-          <a:xfrm>
-            <a:off x="960120" y="3703320"/>
-            <a:ext cx="4297680" cy="731520"/>
-          </a:xfrm>
-          <a:prstGeom prst="rect">
-            <a:avLst/>
-          </a:prstGeom>
-          <a:noFill/>
-          <a:ln/>
-        </p:spPr>
-        <p:txBody>
-          <a:bodyPr wrap="square" lIns="0" tIns="0" rIns="0" bIns="0" rtlCol="0" anchor="t"/>
-          <a:lstStyle/>
-          <a:p>
-            <a:pPr indent="0" marL="0">
-              <a:buNone/>
-            </a:pPr>
-            <a:r>
-              <a:rPr lang="en-US" sz="1300" dirty="0">
-                <a:solidFill>
-                  <a:srgbClr val="00212B"/>
-                </a:solidFill>
-                <a:latin typeface="Montserrat" pitchFamily="34" charset="0"/>
-                <a:ea typeface="Montserrat" pitchFamily="34" charset="-122"/>
-                <a:cs typeface="Montserrat" pitchFamily="34" charset="-120"/>
-              </a:rPr>
-              <a:t>Turn on App lock under My conferences, menu, Privacy, to ask for your fingerprint, face or PIN.</a:t>
-            </a:r>
-            <a:endParaRPr lang="en-US" sz="1300" dirty="0"/>
-          </a:p>
-        </p:txBody>
-      </p:sp>
-      <p:sp>
-        <p:nvSpPr>
-          <p:cNvPr id="15" name="Shape 13"/>
-          <p:cNvSpPr/>
-          <p:nvPr/>
-        </p:nvSpPr>
-        <p:spPr>
-          <a:xfrm>
-            <a:off x="6748272" y="438912"/>
-            <a:ext cx="1876806" cy="4014216"/>
+            <a:off x="6611112" y="438912"/>
+            <a:ext cx="1979676" cy="4242816"/>
           </a:xfrm>
           <a:prstGeom prst="roundRect">
             <a:avLst>
-              <a:gd name="adj" fmla="val 8770"/>
+              <a:gd name="adj" fmla="val 8314"/>
             </a:avLst>
           </a:prstGeom>
           <a:solidFill>
@@ -5360,7 +5451,7 @@
       </p:sp>
       <p:pic>
         <p:nvPicPr>
-          <p:cNvPr id="16" name="Image 0" descr="Attenlume screen: privacy">    </p:cNvPr>
+          <p:cNvPr id="8" name="Image 0" descr="Attenlume screen: settings">    </p:cNvPr>
           <p:cNvPicPr>
             <a:picLocks noChangeAspect="1"/>
           </p:cNvPicPr>
@@ -5374,62 +5465,14 @@
         </p:blipFill>
         <p:spPr>
           <a:xfrm>
-            <a:off x="6812280" y="502920"/>
-            <a:ext cx="1748790" cy="3886200"/>
+            <a:off x="6675120" y="502920"/>
+            <a:ext cx="1851660" cy="4114800"/>
           </a:xfrm>
           <a:prstGeom prst="rect">
             <a:avLst/>
           </a:prstGeom>
         </p:spPr>
       </p:pic>
-      <p:sp>
-        <p:nvSpPr>
-          <p:cNvPr id="25" name="Slide Number Placeholder 0"/>
-          <p:cNvSpPr>
-            <a:spLocks noGrp="1"/>
-          </p:cNvSpPr>
-          <p:nvPr>
-            <p:ph type="sldNum" sz="quarter" idx="4294967295"/>
-          </p:nvPr>
-        </p:nvSpPr>
-        <p:spPr>
-          <a:xfrm>
-            <a:off x="8321040" y="4754880"/>
-            <a:ext cx="365760" cy="274320"/>
-          </a:xfrm>
-          <a:prstGeom prst="rect">
-            <a:avLst/>
-          </a:prstGeom>
-          <a:extLst>
-            <a:ext uri="{C572A759-6A51-4108-AA02-DFA0A04FC94B}">
-              <ma14:wrappingTextBoxFlag xmlns:ma14="http://schemas.microsoft.com/office/mac/drawingml/2011/main" val="0"/>
-            </a:ext>
-          </a:extLst>
-        </p:spPr>
-        <p:txBody>
-          <a:bodyPr/>
-          <a:lstStyle>
-            <a:lvl1pPr>
-              <a:defRPr sz="900">
-                <a:solidFill>
-                  <a:srgbClr val="5B6B70"/>
-                </a:solidFill>
-                <a:latin typeface="Montserrat"/>
-                <a:ea typeface="Montserrat"/>
-                <a:cs typeface="Montserrat"/>
-              </a:defRPr>
-            </a:lvl1pPr>
-          </a:lstStyle>
-          <a:p>
-            <a:pPr algn="r"/>
-            <a:fld id="{F7021451-1387-4CA6-816F-3879F97B5CBC}" type="slidenum">
-              <a:rPr b="0" lang="en-US"/>
-              <a:t>16</a:t>
-            </a:fld>
-            <a:endParaRPr lang="en-US"/>
-          </a:p>
-        </p:txBody>
-      </p:sp>
     </p:spTree>
   </p:cSld>
   <p:clrMapOvr>
@@ -5457,65 +5500,26 @@
       </p:grpSpPr>
       <p:sp>
         <p:nvSpPr>
-          <p:cNvPr id="2" name="Text 0"/>
-          <p:cNvSpPr txBox="1"/>
+          <p:cNvPr id="2" name="Shape 0"/>
+          <p:cNvSpPr/>
           <p:nvPr/>
         </p:nvSpPr>
         <p:spPr>
           <a:xfrm>
             <a:off x="457200" y="411480"/>
-            <a:ext cx="8229600" cy="640080"/>
-          </a:xfrm>
-          <a:prstGeom prst="rect">
-            <a:avLst/>
-          </a:prstGeom>
-          <a:noFill/>
-          <a:ln/>
-        </p:spPr>
-        <p:txBody>
-          <a:bodyPr wrap="square" lIns="0" tIns="0" rIns="0" bIns="0" rtlCol="0" anchor="ctr"/>
-          <a:lstStyle/>
-          <a:p>
-            <a:pPr indent="0" marL="0">
-              <a:buNone/>
-            </a:pPr>
-            <a:r>
-              <a:rPr lang="en-US" sz="3000" b="1" dirty="0">
-                <a:solidFill>
-                  <a:srgbClr val="4392F1"/>
-                </a:solidFill>
-                <a:latin typeface="Montserrat" pitchFamily="34" charset="0"/>
-                <a:ea typeface="Montserrat" pitchFamily="34" charset="-122"/>
-                <a:cs typeface="Montserrat" pitchFamily="34" charset="-120"/>
-              </a:rPr>
-              <a:t>Good to know</a:t>
-            </a:r>
-            <a:endParaRPr lang="en-US" sz="3000" dirty="0"/>
-          </a:p>
-        </p:txBody>
-      </p:sp>
-      <p:sp>
-        <p:nvSpPr>
-          <p:cNvPr id="3" name="Shape 1"/>
-          <p:cNvSpPr/>
-          <p:nvPr/>
-        </p:nvSpPr>
-        <p:spPr>
-          <a:xfrm>
-            <a:off x="457200" y="1234440"/>
-            <a:ext cx="3977640" cy="1463040"/>
+            <a:ext cx="1737360" cy="310896"/>
           </a:xfrm>
           <a:prstGeom prst="roundRect">
             <a:avLst>
-              <a:gd name="adj" fmla="val 9375"/>
+              <a:gd name="adj" fmla="val 50000"/>
             </a:avLst>
           </a:prstGeom>
           <a:solidFill>
-            <a:srgbClr val="EAF2FD"/>
+            <a:srgbClr val="DCFF38"/>
           </a:solidFill>
           <a:ln w="12700">
             <a:solidFill>
-              <a:srgbClr val="EAF2FD"/>
+              <a:srgbClr val="DCFF38"/>
             </a:solidFill>
             <a:prstDash val="solid"/>
           </a:ln>
@@ -5523,14 +5527,53 @@
       </p:sp>
       <p:sp>
         <p:nvSpPr>
+          <p:cNvPr id="3" name="Text 1"/>
+          <p:cNvSpPr txBox="1"/>
+          <p:nvPr/>
+        </p:nvSpPr>
+        <p:spPr>
+          <a:xfrm>
+            <a:off x="457200" y="411480"/>
+            <a:ext cx="1737360" cy="310896"/>
+          </a:xfrm>
+          <a:prstGeom prst="rect">
+            <a:avLst/>
+          </a:prstGeom>
+          <a:noFill/>
+          <a:ln/>
+        </p:spPr>
+        <p:txBody>
+          <a:bodyPr wrap="square" lIns="0" tIns="0" rIns="0" bIns="0" rtlCol="0" anchor="ctr"/>
+          <a:lstStyle/>
+          <a:p>
+            <a:pPr algn="ctr" indent="0" marL="0">
+              <a:buNone/>
+            </a:pPr>
+            <a:r>
+              <a:rPr lang="en-US" sz="1100" b="1" dirty="0">
+                <a:solidFill>
+                  <a:srgbClr val="00212B"/>
+                </a:solidFill>
+                <a:latin typeface="Montserrat" pitchFamily="34" charset="0"/>
+                <a:ea typeface="Montserrat" pitchFamily="34" charset="-122"/>
+                <a:cs typeface="Montserrat" pitchFamily="34" charset="-120"/>
+              </a:rPr>
+              <a:t>5  Settings and storage</a:t>
+            </a:r>
+            <a:endParaRPr lang="en-US" sz="1100" dirty="0"/>
+          </a:p>
+        </p:txBody>
+      </p:sp>
+      <p:sp>
+        <p:nvSpPr>
           <p:cNvPr id="4" name="Text 2"/>
           <p:cNvSpPr txBox="1"/>
           <p:nvPr/>
         </p:nvSpPr>
         <p:spPr>
           <a:xfrm>
-            <a:off x="685800" y="1417320"/>
-            <a:ext cx="3520440" cy="365760"/>
+            <a:off x="457200" y="868680"/>
+            <a:ext cx="3881628" cy="777240"/>
           </a:xfrm>
           <a:prstGeom prst="rect">
             <a:avLst/>
@@ -5539,14 +5582,14 @@
           <a:ln/>
         </p:spPr>
         <p:txBody>
-          <a:bodyPr wrap="square" lIns="0" tIns="0" rIns="0" bIns="0" rtlCol="0" anchor="ctr"/>
+          <a:bodyPr wrap="square" lIns="0" tIns="0" rIns="0" bIns="0" rtlCol="0" anchor="t"/>
           <a:lstStyle/>
           <a:p>
             <a:pPr indent="0" marL="0">
               <a:buNone/>
             </a:pPr>
             <a:r>
-              <a:rPr lang="en-US" sz="1600" b="1" dirty="0">
+              <a:rPr lang="en-US" sz="2400" b="1" dirty="0">
                 <a:solidFill>
                   <a:srgbClr val="4392F1"/>
                 </a:solidFill>
@@ -5554,9 +5597,9 @@
                 <a:ea typeface="Montserrat" pitchFamily="34" charset="-122"/>
                 <a:cs typeface="Montserrat" pitchFamily="34" charset="-120"/>
               </a:rPr>
-              <a:t>Ask before you record</a:t>
-            </a:r>
-            <a:endParaRPr lang="en-US" sz="1600" dirty="0"/>
+              <a:t>Settings</a:t>
+            </a:r>
+            <a:endParaRPr lang="en-US" sz="2400" dirty="0"/>
           </a:p>
         </p:txBody>
       </p:sp>
@@ -5568,8 +5611,8 @@
         </p:nvSpPr>
         <p:spPr>
           <a:xfrm>
-            <a:off x="685800" y="1828800"/>
-            <a:ext cx="3520440" cy="731520"/>
+            <a:off x="457200" y="1783080"/>
+            <a:ext cx="3881628" cy="2743200"/>
           </a:xfrm>
           <a:prstGeom prst="rect">
             <a:avLst/>
@@ -5581,11 +5624,15 @@
           <a:bodyPr wrap="square" lIns="0" tIns="0" rIns="0" bIns="0" rtlCol="0" anchor="t"/>
           <a:lstStyle/>
           <a:p>
-            <a:pPr indent="0" marL="0">
-              <a:buNone/>
-            </a:pPr>
-            <a:r>
-              <a:rPr lang="en-US" sz="1300" dirty="0">
+            <a:pPr marL="190500" indent="-190500">
+              <a:spcAft>
+                <a:spcPts val="1000"/>
+              </a:spcAft>
+              <a:buSzPct val="100000"/>
+              <a:buChar char="•"/>
+            </a:pPr>
+            <a:r>
+              <a:rPr lang="en-US" sz="1400" dirty="0">
                 <a:solidFill>
                   <a:srgbClr val="00212B"/>
                 </a:solidFill>
@@ -5593,9 +5640,51 @@
                 <a:ea typeface="Montserrat" pitchFamily="34" charset="-122"/>
                 <a:cs typeface="Montserrat" pitchFamily="34" charset="-120"/>
               </a:rPr>
-              <a:t>Some events and speakers do not allow recording. Record only when permitted.</a:t>
-            </a:r>
-            <a:endParaRPr lang="en-US" sz="1300" dirty="0"/>
+              <a:t>On My conferences, tap the menu, then Settings.</a:t>
+            </a:r>
+            <a:endParaRPr lang="en-US" sz="1400" dirty="0"/>
+          </a:p>
+          <a:p>
+            <a:pPr marL="190500" indent="-190500">
+              <a:spcAft>
+                <a:spcPts val="1000"/>
+              </a:spcAft>
+              <a:buSzPct val="100000"/>
+              <a:buChar char="•"/>
+            </a:pPr>
+            <a:r>
+              <a:rPr lang="en-US" sz="1400" dirty="0">
+                <a:solidFill>
+                  <a:srgbClr val="00212B"/>
+                </a:solidFill>
+                <a:latin typeface="Montserrat" pitchFamily="34" charset="0"/>
+                <a:ea typeface="Montserrat" pitchFamily="34" charset="-122"/>
+                <a:cs typeface="Montserrat" pitchFamily="34" charset="-120"/>
+              </a:rPr>
+              <a:t>Choose the default recording quality, when Attenlume checks in during long recordings, photo quality and the theme.</a:t>
+            </a:r>
+            <a:endParaRPr lang="en-US" sz="1400" dirty="0"/>
+          </a:p>
+          <a:p>
+            <a:pPr marL="190500" indent="-190500">
+              <a:spcAft>
+                <a:spcPts val="1000"/>
+              </a:spcAft>
+              <a:buSzPct val="100000"/>
+              <a:buChar char="•"/>
+            </a:pPr>
+            <a:r>
+              <a:rPr lang="en-US" sz="1400" dirty="0">
+                <a:solidFill>
+                  <a:srgbClr val="00212B"/>
+                </a:solidFill>
+                <a:latin typeface="Montserrat" pitchFamily="34" charset="0"/>
+                <a:ea typeface="Montserrat" pitchFamily="34" charset="-122"/>
+                <a:cs typeface="Montserrat" pitchFamily="34" charset="-120"/>
+              </a:rPr>
+              <a:t>Privacy and app lock, the quick guide and About are here too.</a:t>
+            </a:r>
+            <a:endParaRPr lang="en-US" sz="1400" dirty="0"/>
           </a:p>
         </p:txBody>
       </p:sp>
@@ -5607,313 +5696,114 @@
         </p:nvSpPr>
         <p:spPr>
           <a:xfrm>
-            <a:off x="4709160" y="1234440"/>
-            <a:ext cx="3977640" cy="1463040"/>
+            <a:off x="4658868" y="438912"/>
+            <a:ext cx="1876806" cy="4014216"/>
           </a:xfrm>
           <a:prstGeom prst="roundRect">
             <a:avLst>
-              <a:gd name="adj" fmla="val 9375"/>
+              <a:gd name="adj" fmla="val 8770"/>
             </a:avLst>
           </a:prstGeom>
           <a:solidFill>
-            <a:srgbClr val="EAF2FD"/>
+            <a:srgbClr val="00212B"/>
           </a:solidFill>
           <a:ln w="12700">
             <a:solidFill>
-              <a:srgbClr val="EAF2FD"/>
+              <a:srgbClr val="00212B"/>
             </a:solidFill>
             <a:prstDash val="solid"/>
           </a:ln>
-        </p:spPr>
-      </p:sp>
-      <p:sp>
-        <p:nvSpPr>
-          <p:cNvPr id="7" name="Text 5"/>
-          <p:cNvSpPr txBox="1"/>
-          <p:nvPr/>
-        </p:nvSpPr>
-        <p:spPr>
-          <a:xfrm>
-            <a:off x="4937760" y="1417320"/>
-            <a:ext cx="3520440" cy="365760"/>
-          </a:xfrm>
-          <a:prstGeom prst="rect">
-            <a:avLst/>
-          </a:prstGeom>
-          <a:noFill/>
-          <a:ln/>
-        </p:spPr>
-        <p:txBody>
-          <a:bodyPr wrap="square" lIns="0" tIns="0" rIns="0" bIns="0" rtlCol="0" anchor="ctr"/>
-          <a:lstStyle/>
-          <a:p>
-            <a:pPr indent="0" marL="0">
-              <a:buNone/>
-            </a:pPr>
-            <a:r>
-              <a:rPr lang="en-US" sz="1600" b="1" dirty="0">
-                <a:solidFill>
-                  <a:srgbClr val="4392F1"/>
-                </a:solidFill>
-                <a:latin typeface="Montserrat" pitchFamily="34" charset="0"/>
-                <a:ea typeface="Montserrat" pitchFamily="34" charset="-122"/>
-                <a:cs typeface="Montserrat" pitchFamily="34" charset="-120"/>
-              </a:rPr>
-              <a:t>Long sessions</a:t>
-            </a:r>
-            <a:endParaRPr lang="en-US" sz="1600" dirty="0"/>
-          </a:p>
-        </p:txBody>
-      </p:sp>
-      <p:sp>
-        <p:nvSpPr>
-          <p:cNvPr id="8" name="Text 6"/>
-          <p:cNvSpPr txBox="1"/>
-          <p:nvPr/>
-        </p:nvSpPr>
-        <p:spPr>
-          <a:xfrm>
-            <a:off x="4937760" y="1828800"/>
-            <a:ext cx="3520440" cy="731520"/>
-          </a:xfrm>
-          <a:prstGeom prst="rect">
-            <a:avLst/>
-          </a:prstGeom>
-          <a:noFill/>
-          <a:ln/>
-        </p:spPr>
-        <p:txBody>
-          <a:bodyPr wrap="square" lIns="0" tIns="0" rIns="0" bIns="0" rtlCol="0" anchor="t"/>
-          <a:lstStyle/>
-          <a:p>
-            <a:pPr indent="0" marL="0">
-              <a:buNone/>
-            </a:pPr>
-            <a:r>
-              <a:rPr lang="en-US" sz="1300" dirty="0">
-                <a:solidFill>
-                  <a:srgbClr val="00212B"/>
-                </a:solidFill>
-                <a:latin typeface="Montserrat" pitchFamily="34" charset="0"/>
-                <a:ea typeface="Montserrat" pitchFamily="34" charset="-122"/>
-                <a:cs typeface="Montserrat" pitchFamily="34" charset="-120"/>
-              </a:rPr>
-              <a:t>Attenlume checks in after two hours, after ten minutes of silence and when the battery is low.</a:t>
-            </a:r>
-            <a:endParaRPr lang="en-US" sz="1300" dirty="0"/>
-          </a:p>
-        </p:txBody>
-      </p:sp>
-      <p:sp>
-        <p:nvSpPr>
-          <p:cNvPr id="9" name="Shape 7"/>
+          <a:effectLst>
+            <a:outerShdw sx="100000" sy="100000" kx="0" ky="0" algn="bl" rotWithShape="0" blurRad="101600" dist="38100" dir="5400000">
+              <a:srgbClr val="000000">
+                <a:alpha val="18000"/>
+              </a:srgbClr>
+            </a:outerShdw>
+          </a:effectLst>
+        </p:spPr>
+      </p:sp>
+      <p:pic>
+        <p:nvPicPr>
+          <p:cNvPr id="7" name="Image 0" descr="Attenlume screen: menu">    </p:cNvPr>
+          <p:cNvPicPr>
+            <a:picLocks noChangeAspect="1"/>
+          </p:cNvPicPr>
+          <p:nvPr/>
+        </p:nvPicPr>
+        <p:blipFill>
+          <a:blip r:embed="rId1"/>
+          <a:stretch>
+            <a:fillRect/>
+          </a:stretch>
+        </p:blipFill>
+        <p:spPr>
+          <a:xfrm>
+            <a:off x="4722876" y="502920"/>
+            <a:ext cx="1748790" cy="3886200"/>
+          </a:xfrm>
+          <a:prstGeom prst="rect">
+            <a:avLst/>
+          </a:prstGeom>
+        </p:spPr>
+      </p:pic>
+      <p:sp>
+        <p:nvSpPr>
+          <p:cNvPr id="8" name="Shape 5"/>
           <p:cNvSpPr/>
           <p:nvPr/>
         </p:nvSpPr>
         <p:spPr>
           <a:xfrm>
-            <a:off x="457200" y="2926080"/>
-            <a:ext cx="3977640" cy="1463040"/>
+            <a:off x="6809994" y="438912"/>
+            <a:ext cx="1876806" cy="4014216"/>
           </a:xfrm>
           <a:prstGeom prst="roundRect">
             <a:avLst>
-              <a:gd name="adj" fmla="val 9375"/>
+              <a:gd name="adj" fmla="val 8770"/>
             </a:avLst>
           </a:prstGeom>
           <a:solidFill>
-            <a:srgbClr val="EAF2FD"/>
+            <a:srgbClr val="00212B"/>
           </a:solidFill>
           <a:ln w="12700">
             <a:solidFill>
-              <a:srgbClr val="EAF2FD"/>
+              <a:srgbClr val="00212B"/>
             </a:solidFill>
             <a:prstDash val="solid"/>
           </a:ln>
-        </p:spPr>
-      </p:sp>
-      <p:sp>
-        <p:nvSpPr>
-          <p:cNvPr id="10" name="Text 8"/>
-          <p:cNvSpPr txBox="1"/>
-          <p:nvPr/>
-        </p:nvSpPr>
-        <p:spPr>
-          <a:xfrm>
-            <a:off x="685800" y="3108960"/>
-            <a:ext cx="3520440" cy="365760"/>
-          </a:xfrm>
-          <a:prstGeom prst="rect">
-            <a:avLst/>
-          </a:prstGeom>
-          <a:noFill/>
-          <a:ln/>
-        </p:spPr>
-        <p:txBody>
-          <a:bodyPr wrap="square" lIns="0" tIns="0" rIns="0" bIns="0" rtlCol="0" anchor="ctr"/>
-          <a:lstStyle/>
-          <a:p>
-            <a:pPr indent="0" marL="0">
-              <a:buNone/>
-            </a:pPr>
-            <a:r>
-              <a:rPr lang="en-US" sz="1600" b="1" dirty="0">
-                <a:solidFill>
-                  <a:srgbClr val="4392F1"/>
-                </a:solidFill>
-                <a:latin typeface="Montserrat" pitchFamily="34" charset="0"/>
-                <a:ea typeface="Montserrat" pitchFamily="34" charset="-122"/>
-                <a:cs typeface="Montserrat" pitchFamily="34" charset="-120"/>
-              </a:rPr>
-              <a:t>Updating</a:t>
-            </a:r>
-            <a:endParaRPr lang="en-US" sz="1600" dirty="0"/>
-          </a:p>
-        </p:txBody>
-      </p:sp>
-      <p:sp>
-        <p:nvSpPr>
-          <p:cNvPr id="11" name="Text 9"/>
-          <p:cNvSpPr txBox="1"/>
-          <p:nvPr/>
-        </p:nvSpPr>
-        <p:spPr>
-          <a:xfrm>
-            <a:off x="685800" y="3520440"/>
-            <a:ext cx="3520440" cy="731520"/>
-          </a:xfrm>
-          <a:prstGeom prst="rect">
-            <a:avLst/>
-          </a:prstGeom>
-          <a:noFill/>
-          <a:ln/>
-        </p:spPr>
-        <p:txBody>
-          <a:bodyPr wrap="square" lIns="0" tIns="0" rIns="0" bIns="0" rtlCol="0" anchor="t"/>
-          <a:lstStyle/>
-          <a:p>
-            <a:pPr indent="0" marL="0">
-              <a:buNone/>
-            </a:pPr>
-            <a:r>
-              <a:rPr lang="en-US" sz="1300" dirty="0">
-                <a:solidFill>
-                  <a:srgbClr val="00212B"/>
-                </a:solidFill>
-                <a:latin typeface="Montserrat" pitchFamily="34" charset="0"/>
-                <a:ea typeface="Montserrat" pitchFamily="34" charset="-122"/>
-                <a:cs typeface="Montserrat" pitchFamily="34" charset="-120"/>
-              </a:rPr>
-              <a:t>Installing a newer version keeps all your recordings.</a:t>
-            </a:r>
-            <a:endParaRPr lang="en-US" sz="1300" dirty="0"/>
-          </a:p>
-        </p:txBody>
-      </p:sp>
-      <p:sp>
-        <p:nvSpPr>
-          <p:cNvPr id="12" name="Shape 10"/>
-          <p:cNvSpPr/>
-          <p:nvPr/>
-        </p:nvSpPr>
-        <p:spPr>
-          <a:xfrm>
-            <a:off x="4709160" y="2926080"/>
-            <a:ext cx="3977640" cy="1463040"/>
-          </a:xfrm>
-          <a:prstGeom prst="roundRect">
-            <a:avLst>
-              <a:gd name="adj" fmla="val 9375"/>
-            </a:avLst>
-          </a:prstGeom>
-          <a:solidFill>
-            <a:srgbClr val="EAF2FD"/>
-          </a:solidFill>
-          <a:ln w="12700">
-            <a:solidFill>
-              <a:srgbClr val="EAF2FD"/>
-            </a:solidFill>
-            <a:prstDash val="solid"/>
-          </a:ln>
-        </p:spPr>
-      </p:sp>
-      <p:sp>
-        <p:nvSpPr>
-          <p:cNvPr id="13" name="Text 11"/>
-          <p:cNvSpPr txBox="1"/>
-          <p:nvPr/>
-        </p:nvSpPr>
-        <p:spPr>
-          <a:xfrm>
-            <a:off x="4937760" y="3108960"/>
-            <a:ext cx="3520440" cy="365760"/>
-          </a:xfrm>
-          <a:prstGeom prst="rect">
-            <a:avLst/>
-          </a:prstGeom>
-          <a:noFill/>
-          <a:ln/>
-        </p:spPr>
-        <p:txBody>
-          <a:bodyPr wrap="square" lIns="0" tIns="0" rIns="0" bIns="0" rtlCol="0" anchor="ctr"/>
-          <a:lstStyle/>
-          <a:p>
-            <a:pPr indent="0" marL="0">
-              <a:buNone/>
-            </a:pPr>
-            <a:r>
-              <a:rPr lang="en-US" sz="1600" b="1" dirty="0">
-                <a:solidFill>
-                  <a:srgbClr val="4392F1"/>
-                </a:solidFill>
-                <a:latin typeface="Montserrat" pitchFamily="34" charset="0"/>
-                <a:ea typeface="Montserrat" pitchFamily="34" charset="-122"/>
-                <a:cs typeface="Montserrat" pitchFamily="34" charset="-120"/>
-              </a:rPr>
-              <a:t>Before you uninstall</a:t>
-            </a:r>
-            <a:endParaRPr lang="en-US" sz="1600" dirty="0"/>
-          </a:p>
-        </p:txBody>
-      </p:sp>
-      <p:sp>
-        <p:nvSpPr>
-          <p:cNvPr id="14" name="Text 12"/>
-          <p:cNvSpPr txBox="1"/>
-          <p:nvPr/>
-        </p:nvSpPr>
-        <p:spPr>
-          <a:xfrm>
-            <a:off x="4937760" y="3520440"/>
-            <a:ext cx="3520440" cy="731520"/>
-          </a:xfrm>
-          <a:prstGeom prst="rect">
-            <a:avLst/>
-          </a:prstGeom>
-          <a:noFill/>
-          <a:ln/>
-        </p:spPr>
-        <p:txBody>
-          <a:bodyPr wrap="square" lIns="0" tIns="0" rIns="0" bIns="0" rtlCol="0" anchor="t"/>
-          <a:lstStyle/>
-          <a:p>
-            <a:pPr indent="0" marL="0">
-              <a:buNone/>
-            </a:pPr>
-            <a:r>
-              <a:rPr lang="en-US" sz="1300" dirty="0">
-                <a:solidFill>
-                  <a:srgbClr val="00212B"/>
-                </a:solidFill>
-                <a:latin typeface="Montserrat" pitchFamily="34" charset="0"/>
-                <a:ea typeface="Montserrat" pitchFamily="34" charset="-122"/>
-                <a:cs typeface="Montserrat" pitchFamily="34" charset="-120"/>
-              </a:rPr>
-              <a:t>Uninstalling deletes everything in the app. Export and share your conferences first.</a:t>
-            </a:r>
-            <a:endParaRPr lang="en-US" sz="1300" dirty="0"/>
-          </a:p>
-        </p:txBody>
-      </p:sp>
+          <a:effectLst>
+            <a:outerShdw sx="100000" sy="100000" kx="0" ky="0" algn="bl" rotWithShape="0" blurRad="101600" dist="38100" dir="5400000">
+              <a:srgbClr val="000000">
+                <a:alpha val="18000"/>
+              </a:srgbClr>
+            </a:outerShdw>
+          </a:effectLst>
+        </p:spPr>
+      </p:sp>
+      <p:pic>
+        <p:nvPicPr>
+          <p:cNvPr id="9" name="Image 1" descr="Attenlume screen: settings">    </p:cNvPr>
+          <p:cNvPicPr>
+            <a:picLocks noChangeAspect="1"/>
+          </p:cNvPicPr>
+          <p:nvPr/>
+        </p:nvPicPr>
+        <p:blipFill>
+          <a:blip r:embed="rId2"/>
+          <a:stretch>
+            <a:fillRect/>
+          </a:stretch>
+        </p:blipFill>
+        <p:spPr>
+          <a:xfrm>
+            <a:off x="6874002" y="502920"/>
+            <a:ext cx="1748790" cy="3886200"/>
+          </a:xfrm>
+          <a:prstGeom prst="rect">
+            <a:avLst/>
+          </a:prstGeom>
+        </p:spPr>
+      </p:pic>
       <p:sp>
         <p:nvSpPr>
           <p:cNvPr id="25" name="Slide Number Placeholder 0"/>
@@ -5973,13 +5863,6 @@
 <file path=ppt/slides/slide18.xml><?xml version="1.0" encoding="utf-8"?>
 <p:sld xmlns:a="http://schemas.openxmlformats.org/drawingml/2006/main" xmlns:r="http://schemas.openxmlformats.org/officeDocument/2006/relationships" xmlns:p="http://schemas.openxmlformats.org/presentationml/2006/main">
   <p:cSld name="Slide 18">
-    <p:bg>
-      <p:bgPr>
-        <a:solidFill>
-          <a:srgbClr val="4392F1"/>
-        </a:solidFill>
-      </p:bgPr>
-    </p:bg>
     <p:spTree>
       <p:nvGrpSpPr>
         <p:cNvPr id="1" name=""/>
@@ -6001,40 +5884,13 @@
           <p:nvPr/>
         </p:nvSpPr>
         <p:spPr>
-          <a:xfrm rot="1800000">
-            <a:off x="7863840" y="-320040"/>
-            <a:ext cx="2560320" cy="640080"/>
+          <a:xfrm>
+            <a:off x="457200" y="411480"/>
+            <a:ext cx="1737360" cy="310896"/>
           </a:xfrm>
           <a:prstGeom prst="roundRect">
             <a:avLst>
               <a:gd name="adj" fmla="val 50000"/>
-            </a:avLst>
-          </a:prstGeom>
-          <a:solidFill>
-            <a:srgbClr val="FEFFF8"/>
-          </a:solidFill>
-          <a:ln w="12700">
-            <a:solidFill>
-              <a:srgbClr val="FEFFF8"/>
-            </a:solidFill>
-            <a:prstDash val="solid"/>
-          </a:ln>
-        </p:spPr>
-      </p:sp>
-      <p:sp>
-        <p:nvSpPr>
-          <p:cNvPr id="3" name="Shape 1"/>
-          <p:cNvSpPr/>
-          <p:nvPr/>
-        </p:nvSpPr>
-        <p:spPr>
-          <a:xfrm rot="1800000">
-            <a:off x="8229600" y="502920"/>
-            <a:ext cx="1463040" cy="411480"/>
-          </a:xfrm>
-          <a:prstGeom prst="roundRect">
-            <a:avLst>
-              <a:gd name="adj" fmla="val 48889"/>
             </a:avLst>
           </a:prstGeom>
           <a:solidFill>
@@ -6050,18 +5906,312 @@
       </p:sp>
       <p:sp>
         <p:nvSpPr>
-          <p:cNvPr id="4" name="Shape 2"/>
+          <p:cNvPr id="3" name="Text 1"/>
+          <p:cNvSpPr txBox="1"/>
+          <p:nvPr/>
+        </p:nvSpPr>
+        <p:spPr>
+          <a:xfrm>
+            <a:off x="457200" y="411480"/>
+            <a:ext cx="1737360" cy="310896"/>
+          </a:xfrm>
+          <a:prstGeom prst="rect">
+            <a:avLst/>
+          </a:prstGeom>
+          <a:noFill/>
+          <a:ln/>
+        </p:spPr>
+        <p:txBody>
+          <a:bodyPr wrap="square" lIns="0" tIns="0" rIns="0" bIns="0" rtlCol="0" anchor="ctr"/>
+          <a:lstStyle/>
+          <a:p>
+            <a:pPr algn="ctr" indent="0" marL="0">
+              <a:buNone/>
+            </a:pPr>
+            <a:r>
+              <a:rPr lang="en-US" sz="1100" b="1" dirty="0">
+                <a:solidFill>
+                  <a:srgbClr val="00212B"/>
+                </a:solidFill>
+                <a:latin typeface="Montserrat" pitchFamily="34" charset="0"/>
+                <a:ea typeface="Montserrat" pitchFamily="34" charset="-122"/>
+                <a:cs typeface="Montserrat" pitchFamily="34" charset="-120"/>
+              </a:rPr>
+              <a:t>5  Settings and storage</a:t>
+            </a:r>
+            <a:endParaRPr lang="en-US" sz="1100" dirty="0"/>
+          </a:p>
+        </p:txBody>
+      </p:sp>
+      <p:sp>
+        <p:nvSpPr>
+          <p:cNvPr id="4" name="Text 2"/>
+          <p:cNvSpPr txBox="1"/>
+          <p:nvPr/>
+        </p:nvSpPr>
+        <p:spPr>
+          <a:xfrm>
+            <a:off x="457200" y="868680"/>
+            <a:ext cx="6032754" cy="777240"/>
+          </a:xfrm>
+          <a:prstGeom prst="rect">
+            <a:avLst/>
+          </a:prstGeom>
+          <a:noFill/>
+          <a:ln/>
+        </p:spPr>
+        <p:txBody>
+          <a:bodyPr wrap="square" lIns="0" tIns="0" rIns="0" bIns="0" rtlCol="0" anchor="t"/>
+          <a:lstStyle/>
+          <a:p>
+            <a:pPr indent="0" marL="0">
+              <a:buNone/>
+            </a:pPr>
+            <a:r>
+              <a:rPr lang="en-US" sz="2800" b="1" dirty="0">
+                <a:solidFill>
+                  <a:srgbClr val="4392F1"/>
+                </a:solidFill>
+                <a:latin typeface="Montserrat" pitchFamily="34" charset="0"/>
+                <a:ea typeface="Montserrat" pitchFamily="34" charset="-122"/>
+                <a:cs typeface="Montserrat" pitchFamily="34" charset="-120"/>
+              </a:rPr>
+              <a:t>Storage manager</a:t>
+            </a:r>
+            <a:endParaRPr lang="en-US" sz="2800" dirty="0"/>
+          </a:p>
+        </p:txBody>
+      </p:sp>
+      <p:sp>
+        <p:nvSpPr>
+          <p:cNvPr id="5" name="Text 3"/>
+          <p:cNvSpPr txBox="1"/>
+          <p:nvPr/>
+        </p:nvSpPr>
+        <p:spPr>
+          <a:xfrm>
+            <a:off x="457200" y="1783080"/>
+            <a:ext cx="6032754" cy="2743200"/>
+          </a:xfrm>
+          <a:prstGeom prst="rect">
+            <a:avLst/>
+          </a:prstGeom>
+          <a:noFill/>
+          <a:ln/>
+        </p:spPr>
+        <p:txBody>
+          <a:bodyPr wrap="square" lIns="0" tIns="0" rIns="0" bIns="0" rtlCol="0" anchor="t"/>
+          <a:lstStyle/>
+          <a:p>
+            <a:pPr marL="190500" indent="-190500">
+              <a:spcAft>
+                <a:spcPts val="1000"/>
+              </a:spcAft>
+              <a:buSzPct val="100000"/>
+              <a:buChar char="•"/>
+            </a:pPr>
+            <a:r>
+              <a:rPr lang="en-US" sz="1400" dirty="0">
+                <a:solidFill>
+                  <a:srgbClr val="00212B"/>
+                </a:solidFill>
+                <a:latin typeface="Montserrat" pitchFamily="34" charset="0"/>
+                <a:ea typeface="Montserrat" pitchFamily="34" charset="-122"/>
+                <a:cs typeface="Montserrat" pitchFamily="34" charset="-120"/>
+              </a:rPr>
+              <a:t>See how much space each conference uses, and whether it is exported, partly exported or verified.</a:t>
+            </a:r>
+            <a:endParaRPr lang="en-US" sz="1400" dirty="0"/>
+          </a:p>
+          <a:p>
+            <a:pPr marL="190500" indent="-190500">
+              <a:spcAft>
+                <a:spcPts val="1000"/>
+              </a:spcAft>
+              <a:buSzPct val="100000"/>
+              <a:buChar char="•"/>
+            </a:pPr>
+            <a:r>
+              <a:rPr lang="en-US" sz="1400" dirty="0">
+                <a:solidFill>
+                  <a:srgbClr val="00212B"/>
+                </a:solidFill>
+                <a:latin typeface="Montserrat" pitchFamily="34" charset="0"/>
+                <a:ea typeface="Montserrat" pitchFamily="34" charset="-122"/>
+                <a:cs typeface="Montserrat" pitchFamily="34" charset="-120"/>
+              </a:rPr>
+              <a:t>Clear temporary files at any time. Your recordings and photos are never touched.</a:t>
+            </a:r>
+            <a:endParaRPr lang="en-US" sz="1400" dirty="0"/>
+          </a:p>
+          <a:p>
+            <a:pPr marL="190500" indent="-190500">
+              <a:spcAft>
+                <a:spcPts val="1000"/>
+              </a:spcAft>
+              <a:buSzPct val="100000"/>
+              <a:buChar char="•"/>
+            </a:pPr>
+            <a:r>
+              <a:rPr lang="en-US" sz="1400" dirty="0">
+                <a:solidFill>
+                  <a:srgbClr val="00212B"/>
+                </a:solidFill>
+                <a:latin typeface="Montserrat" pitchFamily="34" charset="0"/>
+                <a:ea typeface="Montserrat" pitchFamily="34" charset="-122"/>
+                <a:cs typeface="Montserrat" pitchFamily="34" charset="-120"/>
+              </a:rPr>
+              <a:t>Delete local copies is only possible after a complete, verified export of a folder, with a preview and a second confirmation.</a:t>
+            </a:r>
+            <a:endParaRPr lang="en-US" sz="1400" dirty="0"/>
+          </a:p>
+        </p:txBody>
+      </p:sp>
+      <p:sp>
+        <p:nvSpPr>
+          <p:cNvPr id="6" name="Shape 4"/>
           <p:cNvSpPr/>
           <p:nvPr/>
         </p:nvSpPr>
         <p:spPr>
-          <a:xfrm rot="1800000">
-            <a:off x="-640080" y="4617720"/>
-            <a:ext cx="2011680" cy="502920"/>
+          <a:xfrm>
+            <a:off x="6809994" y="438912"/>
+            <a:ext cx="1876806" cy="4014216"/>
           </a:xfrm>
           <a:prstGeom prst="roundRect">
             <a:avLst>
-              <a:gd name="adj" fmla="val 49091"/>
+              <a:gd name="adj" fmla="val 8770"/>
+            </a:avLst>
+          </a:prstGeom>
+          <a:solidFill>
+            <a:srgbClr val="00212B"/>
+          </a:solidFill>
+          <a:ln w="12700">
+            <a:solidFill>
+              <a:srgbClr val="00212B"/>
+            </a:solidFill>
+            <a:prstDash val="solid"/>
+          </a:ln>
+          <a:effectLst>
+            <a:outerShdw sx="100000" sy="100000" kx="0" ky="0" algn="bl" rotWithShape="0" blurRad="101600" dist="38100" dir="5400000">
+              <a:srgbClr val="000000">
+                <a:alpha val="18000"/>
+              </a:srgbClr>
+            </a:outerShdw>
+          </a:effectLst>
+        </p:spPr>
+      </p:sp>
+      <p:pic>
+        <p:nvPicPr>
+          <p:cNvPr id="7" name="Image 0" descr="Attenlume screen: storage">    </p:cNvPr>
+          <p:cNvPicPr>
+            <a:picLocks noChangeAspect="1"/>
+          </p:cNvPicPr>
+          <p:nvPr/>
+        </p:nvPicPr>
+        <p:blipFill>
+          <a:blip r:embed="rId1"/>
+          <a:stretch>
+            <a:fillRect/>
+          </a:stretch>
+        </p:blipFill>
+        <p:spPr>
+          <a:xfrm>
+            <a:off x="6874002" y="502920"/>
+            <a:ext cx="1748790" cy="3886200"/>
+          </a:xfrm>
+          <a:prstGeom prst="rect">
+            <a:avLst/>
+          </a:prstGeom>
+        </p:spPr>
+      </p:pic>
+      <p:sp>
+        <p:nvSpPr>
+          <p:cNvPr id="25" name="Slide Number Placeholder 0"/>
+          <p:cNvSpPr>
+            <a:spLocks noGrp="1"/>
+          </p:cNvSpPr>
+          <p:nvPr>
+            <p:ph type="sldNum" sz="quarter" idx="4294967295"/>
+          </p:nvPr>
+        </p:nvSpPr>
+        <p:spPr>
+          <a:xfrm>
+            <a:off x="8321040" y="4754880"/>
+            <a:ext cx="365760" cy="274320"/>
+          </a:xfrm>
+          <a:prstGeom prst="rect">
+            <a:avLst/>
+          </a:prstGeom>
+          <a:extLst>
+            <a:ext uri="{C572A759-6A51-4108-AA02-DFA0A04FC94B}">
+              <ma14:wrappingTextBoxFlag xmlns:ma14="http://schemas.microsoft.com/office/mac/drawingml/2011/main" val="0"/>
+            </a:ext>
+          </a:extLst>
+        </p:spPr>
+        <p:txBody>
+          <a:bodyPr/>
+          <a:lstStyle>
+            <a:lvl1pPr>
+              <a:defRPr sz="900">
+                <a:solidFill>
+                  <a:srgbClr val="5B6B70"/>
+                </a:solidFill>
+                <a:latin typeface="Montserrat"/>
+                <a:ea typeface="Montserrat"/>
+                <a:cs typeface="Montserrat"/>
+              </a:defRPr>
+            </a:lvl1pPr>
+          </a:lstStyle>
+          <a:p>
+            <a:pPr algn="r"/>
+            <a:fld id="{F7021451-1387-4CA6-816F-3879F97B5CBC}" type="slidenum">
+              <a:rPr b="0" lang="en-US"/>
+              <a:t>18</a:t>
+            </a:fld>
+            <a:endParaRPr lang="en-US"/>
+          </a:p>
+        </p:txBody>
+      </p:sp>
+    </p:spTree>
+  </p:cSld>
+  <p:clrMapOvr>
+    <a:masterClrMapping/>
+  </p:clrMapOvr>
+</p:sld>
+</file>
+
+<file path=ppt/slides/slide19.xml><?xml version="1.0" encoding="utf-8"?>
+<p:sld xmlns:a="http://schemas.openxmlformats.org/drawingml/2006/main" xmlns:r="http://schemas.openxmlformats.org/officeDocument/2006/relationships" xmlns:p="http://schemas.openxmlformats.org/presentationml/2006/main">
+  <p:cSld name="Slide 19">
+    <p:spTree>
+      <p:nvGrpSpPr>
+        <p:cNvPr id="1" name=""/>
+        <p:cNvGrpSpPr/>
+        <p:nvPr/>
+      </p:nvGrpSpPr>
+      <p:grpSpPr>
+        <a:xfrm>
+          <a:off x="0" y="0"/>
+          <a:ext cx="0" cy="0"/>
+          <a:chOff x="0" y="0"/>
+          <a:chExt cx="0" cy="0"/>
+        </a:xfrm>
+      </p:grpSpPr>
+      <p:sp>
+        <p:nvSpPr>
+          <p:cNvPr id="2" name="Shape 0"/>
+          <p:cNvSpPr/>
+          <p:nvPr/>
+        </p:nvSpPr>
+        <p:spPr>
+          <a:xfrm>
+            <a:off x="457200" y="411480"/>
+            <a:ext cx="1737360" cy="310896"/>
+          </a:xfrm>
+          <a:prstGeom prst="roundRect">
+            <a:avLst>
+              <a:gd name="adj" fmla="val 50000"/>
             </a:avLst>
           </a:prstGeom>
           <a:solidFill>
@@ -6075,9 +6225,206 @@
           </a:ln>
         </p:spPr>
       </p:sp>
+      <p:sp>
+        <p:nvSpPr>
+          <p:cNvPr id="3" name="Text 1"/>
+          <p:cNvSpPr txBox="1"/>
+          <p:nvPr/>
+        </p:nvSpPr>
+        <p:spPr>
+          <a:xfrm>
+            <a:off x="457200" y="411480"/>
+            <a:ext cx="1737360" cy="310896"/>
+          </a:xfrm>
+          <a:prstGeom prst="rect">
+            <a:avLst/>
+          </a:prstGeom>
+          <a:noFill/>
+          <a:ln/>
+        </p:spPr>
+        <p:txBody>
+          <a:bodyPr wrap="square" lIns="0" tIns="0" rIns="0" bIns="0" rtlCol="0" anchor="ctr"/>
+          <a:lstStyle/>
+          <a:p>
+            <a:pPr algn="ctr" indent="0" marL="0">
+              <a:buNone/>
+            </a:pPr>
+            <a:r>
+              <a:rPr lang="en-US" sz="1100" b="1" dirty="0">
+                <a:solidFill>
+                  <a:srgbClr val="00212B"/>
+                </a:solidFill>
+                <a:latin typeface="Montserrat" pitchFamily="34" charset="0"/>
+                <a:ea typeface="Montserrat" pitchFamily="34" charset="-122"/>
+                <a:cs typeface="Montserrat" pitchFamily="34" charset="-120"/>
+              </a:rPr>
+              <a:t>5  Settings and storage</a:t>
+            </a:r>
+            <a:endParaRPr lang="en-US" sz="1100" dirty="0"/>
+          </a:p>
+        </p:txBody>
+      </p:sp>
+      <p:sp>
+        <p:nvSpPr>
+          <p:cNvPr id="4" name="Text 2"/>
+          <p:cNvSpPr txBox="1"/>
+          <p:nvPr/>
+        </p:nvSpPr>
+        <p:spPr>
+          <a:xfrm>
+            <a:off x="457200" y="868680"/>
+            <a:ext cx="6032754" cy="777240"/>
+          </a:xfrm>
+          <a:prstGeom prst="rect">
+            <a:avLst/>
+          </a:prstGeom>
+          <a:noFill/>
+          <a:ln/>
+        </p:spPr>
+        <p:txBody>
+          <a:bodyPr wrap="square" lIns="0" tIns="0" rIns="0" bIns="0" rtlCol="0" anchor="t"/>
+          <a:lstStyle/>
+          <a:p>
+            <a:pPr indent="0" marL="0">
+              <a:buNone/>
+            </a:pPr>
+            <a:r>
+              <a:rPr lang="en-US" sz="2800" b="1" dirty="0">
+                <a:solidFill>
+                  <a:srgbClr val="4392F1"/>
+                </a:solidFill>
+                <a:latin typeface="Montserrat" pitchFamily="34" charset="0"/>
+                <a:ea typeface="Montserrat" pitchFamily="34" charset="-122"/>
+                <a:cs typeface="Montserrat" pitchFamily="34" charset="-120"/>
+              </a:rPr>
+              <a:t>Moving to a new device</a:t>
+            </a:r>
+            <a:endParaRPr lang="en-US" sz="2800" dirty="0"/>
+          </a:p>
+        </p:txBody>
+      </p:sp>
+      <p:sp>
+        <p:nvSpPr>
+          <p:cNvPr id="5" name="Text 3"/>
+          <p:cNvSpPr txBox="1"/>
+          <p:nvPr/>
+        </p:nvSpPr>
+        <p:spPr>
+          <a:xfrm>
+            <a:off x="457200" y="1783080"/>
+            <a:ext cx="6032754" cy="2743200"/>
+          </a:xfrm>
+          <a:prstGeom prst="rect">
+            <a:avLst/>
+          </a:prstGeom>
+          <a:noFill/>
+          <a:ln/>
+        </p:spPr>
+        <p:txBody>
+          <a:bodyPr wrap="square" lIns="0" tIns="0" rIns="0" bIns="0" rtlCol="0" anchor="t"/>
+          <a:lstStyle/>
+          <a:p>
+            <a:pPr marL="190500" indent="-190500">
+              <a:spcAft>
+                <a:spcPts val="1000"/>
+              </a:spcAft>
+              <a:buSzPct val="100000"/>
+              <a:buChar char="•"/>
+            </a:pPr>
+            <a:r>
+              <a:rPr lang="en-US" sz="1400" dirty="0">
+                <a:solidFill>
+                  <a:srgbClr val="00212B"/>
+                </a:solidFill>
+                <a:latin typeface="Montserrat" pitchFamily="34" charset="0"/>
+                <a:ea typeface="Montserrat" pitchFamily="34" charset="-122"/>
+                <a:cs typeface="Montserrat" pitchFamily="34" charset="-120"/>
+              </a:rPr>
+              <a:t>Export the conference, then copy the ZIP to the new device.</a:t>
+            </a:r>
+            <a:endParaRPr lang="en-US" sz="1400" dirty="0"/>
+          </a:p>
+          <a:p>
+            <a:pPr marL="190500" indent="-190500">
+              <a:spcAft>
+                <a:spcPts val="1000"/>
+              </a:spcAft>
+              <a:buSzPct val="100000"/>
+              <a:buChar char="•"/>
+            </a:pPr>
+            <a:r>
+              <a:rPr lang="en-US" sz="1400" dirty="0">
+                <a:solidFill>
+                  <a:srgbClr val="00212B"/>
+                </a:solidFill>
+                <a:latin typeface="Montserrat" pitchFamily="34" charset="0"/>
+                <a:ea typeface="Montserrat" pitchFamily="34" charset="-122"/>
+                <a:cs typeface="Montserrat" pitchFamily="34" charset="-120"/>
+              </a:rPr>
+              <a:t>On the new device, tap the menu on My conferences, then Import an export.</a:t>
+            </a:r>
+            <a:endParaRPr lang="en-US" sz="1400" dirty="0"/>
+          </a:p>
+          <a:p>
+            <a:pPr marL="190500" indent="-190500">
+              <a:spcAft>
+                <a:spcPts val="1000"/>
+              </a:spcAft>
+              <a:buSzPct val="100000"/>
+              <a:buChar char="•"/>
+            </a:pPr>
+            <a:r>
+              <a:rPr lang="en-US" sz="1400" dirty="0">
+                <a:solidFill>
+                  <a:srgbClr val="00212B"/>
+                </a:solidFill>
+                <a:latin typeface="Montserrat" pitchFamily="34" charset="0"/>
+                <a:ea typeface="Montserrat" pitchFamily="34" charset="-122"/>
+                <a:cs typeface="Montserrat" pitchFamily="34" charset="-120"/>
+              </a:rPr>
+              <a:t>Every file is checked first, and nothing already in the app is overwritten.</a:t>
+            </a:r>
+            <a:endParaRPr lang="en-US" sz="1400" dirty="0"/>
+          </a:p>
+        </p:txBody>
+      </p:sp>
+      <p:sp>
+        <p:nvSpPr>
+          <p:cNvPr id="6" name="Shape 4"/>
+          <p:cNvSpPr/>
+          <p:nvPr/>
+        </p:nvSpPr>
+        <p:spPr>
+          <a:xfrm>
+            <a:off x="6809994" y="438912"/>
+            <a:ext cx="1876806" cy="4014216"/>
+          </a:xfrm>
+          <a:prstGeom prst="roundRect">
+            <a:avLst>
+              <a:gd name="adj" fmla="val 8770"/>
+            </a:avLst>
+          </a:prstGeom>
+          <a:solidFill>
+            <a:srgbClr val="00212B"/>
+          </a:solidFill>
+          <a:ln w="12700">
+            <a:solidFill>
+              <a:srgbClr val="00212B"/>
+            </a:solidFill>
+            <a:prstDash val="solid"/>
+          </a:ln>
+          <a:effectLst>
+            <a:outerShdw sx="100000" sy="100000" kx="0" ky="0" algn="bl" rotWithShape="0" blurRad="101600" dist="38100" dir="5400000">
+              <a:srgbClr val="000000">
+                <a:alpha val="18000"/>
+              </a:srgbClr>
+            </a:outerShdw>
+          </a:effectLst>
+        </p:spPr>
+      </p:sp>
       <p:pic>
         <p:nvPicPr>
-          <p:cNvPr id="5" name="Image 0" descr="Attenlume app icon">    </p:cNvPr>
+          <p:cNvPr id="7" name="Image 0" descr="Attenlume screen: import">    </p:cNvPr>
           <p:cNvPicPr>
             <a:picLocks noChangeAspect="1"/>
           </p:cNvPicPr>
@@ -6091,8 +6438,8 @@
         </p:blipFill>
         <p:spPr>
           <a:xfrm>
-            <a:off x="4023360" y="822960"/>
-            <a:ext cx="1097280" cy="1097280"/>
+            <a:off x="6874002" y="502920"/>
+            <a:ext cx="1748790" cy="3886200"/>
           </a:xfrm>
           <a:prstGeom prst="rect">
             <a:avLst/>
@@ -6101,135 +6448,49 @@
       </p:pic>
       <p:sp>
         <p:nvSpPr>
-          <p:cNvPr id="6" name="Text 3"/>
-          <p:cNvSpPr txBox="1"/>
-          <p:nvPr/>
-        </p:nvSpPr>
-        <p:spPr>
-          <a:xfrm>
-            <a:off x="685800" y="2148840"/>
-            <a:ext cx="7772400" cy="822960"/>
-          </a:xfrm>
-          <a:prstGeom prst="rect">
-            <a:avLst/>
-          </a:prstGeom>
-          <a:noFill/>
-          <a:ln/>
-        </p:spPr>
-        <p:txBody>
-          <a:bodyPr wrap="square" lIns="0" tIns="0" rIns="0" bIns="0" rtlCol="0" anchor="ctr"/>
-          <a:lstStyle/>
-          <a:p>
-            <a:pPr algn="ctr" indent="0" marL="0">
-              <a:buNone/>
-            </a:pPr>
-            <a:r>
-              <a:rPr lang="en-US" sz="3600" b="1" dirty="0">
-                <a:solidFill>
-                  <a:srgbClr val="FEFFF8"/>
-                </a:solidFill>
-                <a:latin typeface="Montserrat" pitchFamily="34" charset="0"/>
-                <a:ea typeface="Montserrat" pitchFamily="34" charset="-122"/>
-                <a:cs typeface="Montserrat" pitchFamily="34" charset="-120"/>
-              </a:rPr>
-              <a:t>Be present. Bring ideas to light.</a:t>
-            </a:r>
-            <a:endParaRPr lang="en-US" sz="3600" dirty="0"/>
-          </a:p>
-        </p:txBody>
-      </p:sp>
-      <p:sp>
-        <p:nvSpPr>
-          <p:cNvPr id="7" name="Text 4"/>
-          <p:cNvSpPr txBox="1"/>
-          <p:nvPr/>
-        </p:nvSpPr>
-        <p:spPr>
-          <a:xfrm>
-            <a:off x="1371600" y="3108960"/>
-            <a:ext cx="6400800" cy="731520"/>
-          </a:xfrm>
-          <a:prstGeom prst="rect">
-            <a:avLst/>
-          </a:prstGeom>
-          <a:noFill/>
-          <a:ln/>
-        </p:spPr>
-        <p:txBody>
-          <a:bodyPr wrap="square" lIns="0" tIns="0" rIns="0" bIns="0" rtlCol="0" anchor="ctr"/>
-          <a:lstStyle/>
-          <a:p>
-            <a:pPr algn="ctr" indent="0" marL="0">
-              <a:buNone/>
-            </a:pPr>
-            <a:r>
-              <a:rPr lang="en-US" sz="1500" dirty="0">
-                <a:solidFill>
-                  <a:srgbClr val="DCFF38"/>
-                </a:solidFill>
-                <a:latin typeface="Montserrat" pitchFamily="34" charset="0"/>
-                <a:ea typeface="Montserrat" pitchFamily="34" charset="-122"/>
-                <a:cs typeface="Montserrat" pitchFamily="34" charset="-120"/>
-              </a:rPr>
-              <a:t>Download for Android or Windows</a:t>
-            </a:r>
-            <a:endParaRPr lang="en-US" sz="1500" dirty="0"/>
-          </a:p>
-          <a:p>
-            <a:pPr algn="ctr" indent="0" marL="0">
-              <a:buNone/>
-            </a:pPr>
-            <a:r>
-              <a:rPr lang="en-US" sz="1500" b="1" dirty="0">
-                <a:solidFill>
-                  <a:srgbClr val="DCFF38"/>
-                </a:solidFill>
-                <a:latin typeface="Montserrat" pitchFamily="34" charset="0"/>
-                <a:ea typeface="Montserrat" pitchFamily="34" charset="-122"/>
-                <a:cs typeface="Montserrat" pitchFamily="34" charset="-120"/>
-              </a:rPr>
-              <a:t>github.com/SamsonOluwaseun/attenlume</a:t>
-            </a:r>
-            <a:endParaRPr lang="en-US" sz="1500" dirty="0"/>
-          </a:p>
-        </p:txBody>
-      </p:sp>
-      <p:sp>
-        <p:nvSpPr>
-          <p:cNvPr id="8" name="Text 5"/>
-          <p:cNvSpPr txBox="1"/>
-          <p:nvPr/>
-        </p:nvSpPr>
-        <p:spPr>
-          <a:xfrm>
-            <a:off x="1371600" y="4160520"/>
-            <a:ext cx="6400800" cy="274320"/>
-          </a:xfrm>
-          <a:prstGeom prst="rect">
-            <a:avLst/>
-          </a:prstGeom>
-          <a:noFill/>
-          <a:ln/>
-        </p:spPr>
-        <p:txBody>
-          <a:bodyPr wrap="square" lIns="0" tIns="0" rIns="0" bIns="0" rtlCol="0" anchor="ctr"/>
-          <a:lstStyle/>
-          <a:p>
-            <a:pPr algn="ctr" indent="0" marL="0">
-              <a:buNone/>
-            </a:pPr>
-            <a:r>
-              <a:rPr lang="en-US" sz="1100" dirty="0">
-                <a:solidFill>
-                  <a:srgbClr val="FEFFF8"/>
-                </a:solidFill>
-                <a:latin typeface="Montserrat" pitchFamily="34" charset="0"/>
-                <a:ea typeface="Montserrat" pitchFamily="34" charset="-122"/>
-                <a:cs typeface="Montserrat" pitchFamily="34" charset="-120"/>
-              </a:rPr>
-              <a:t>Samlytics Data Services</a:t>
-            </a:r>
-            <a:endParaRPr lang="en-US" sz="1100" dirty="0"/>
+          <p:cNvPr id="25" name="Slide Number Placeholder 0"/>
+          <p:cNvSpPr>
+            <a:spLocks noGrp="1"/>
+          </p:cNvSpPr>
+          <p:nvPr>
+            <p:ph type="sldNum" sz="quarter" idx="4294967295"/>
+          </p:nvPr>
+        </p:nvSpPr>
+        <p:spPr>
+          <a:xfrm>
+            <a:off x="8321040" y="4754880"/>
+            <a:ext cx="365760" cy="274320"/>
+          </a:xfrm>
+          <a:prstGeom prst="rect">
+            <a:avLst/>
+          </a:prstGeom>
+          <a:extLst>
+            <a:ext uri="{C572A759-6A51-4108-AA02-DFA0A04FC94B}">
+              <ma14:wrappingTextBoxFlag xmlns:ma14="http://schemas.microsoft.com/office/mac/drawingml/2011/main" val="0"/>
+            </a:ext>
+          </a:extLst>
+        </p:spPr>
+        <p:txBody>
+          <a:bodyPr/>
+          <a:lstStyle>
+            <a:lvl1pPr>
+              <a:defRPr sz="900">
+                <a:solidFill>
+                  <a:srgbClr val="5B6B70"/>
+                </a:solidFill>
+                <a:latin typeface="Montserrat"/>
+                <a:ea typeface="Montserrat"/>
+                <a:cs typeface="Montserrat"/>
+              </a:defRPr>
+            </a:lvl1pPr>
+          </a:lstStyle>
+          <a:p>
+            <a:pPr algn="r"/>
+            <a:fld id="{F7021451-1387-4CA6-816F-3879F97B5CBC}" type="slidenum">
+              <a:rPr b="0" lang="en-US"/>
+              <a:t>19</a:t>
+            </a:fld>
+            <a:endParaRPr lang="en-US"/>
           </a:p>
         </p:txBody>
       </p:sp>
@@ -7057,6 +7318,1391 @@
               <a:t>2</a:t>
             </a:fld>
             <a:endParaRPr lang="en-US"/>
+          </a:p>
+        </p:txBody>
+      </p:sp>
+    </p:spTree>
+  </p:cSld>
+  <p:clrMapOvr>
+    <a:masterClrMapping/>
+  </p:clrMapOvr>
+</p:sld>
+</file>
+
+<file path=ppt/slides/slide20.xml><?xml version="1.0" encoding="utf-8"?>
+<p:sld xmlns:a="http://schemas.openxmlformats.org/drawingml/2006/main" xmlns:r="http://schemas.openxmlformats.org/officeDocument/2006/relationships" xmlns:p="http://schemas.openxmlformats.org/presentationml/2006/main">
+  <p:cSld name="Slide 20">
+    <p:spTree>
+      <p:nvGrpSpPr>
+        <p:cNvPr id="1" name=""/>
+        <p:cNvGrpSpPr/>
+        <p:nvPr/>
+      </p:nvGrpSpPr>
+      <p:grpSpPr>
+        <a:xfrm>
+          <a:off x="0" y="0"/>
+          <a:ext cx="0" cy="0"/>
+          <a:chOff x="0" y="0"/>
+          <a:chExt cx="0" cy="0"/>
+        </a:xfrm>
+      </p:grpSpPr>
+      <p:sp>
+        <p:nvSpPr>
+          <p:cNvPr id="2" name="Text 0"/>
+          <p:cNvSpPr txBox="1"/>
+          <p:nvPr/>
+        </p:nvSpPr>
+        <p:spPr>
+          <a:xfrm>
+            <a:off x="457200" y="411480"/>
+            <a:ext cx="4754880" cy="640080"/>
+          </a:xfrm>
+          <a:prstGeom prst="rect">
+            <a:avLst/>
+          </a:prstGeom>
+          <a:noFill/>
+          <a:ln/>
+        </p:spPr>
+        <p:txBody>
+          <a:bodyPr wrap="square" lIns="0" tIns="0" rIns="0" bIns="0" rtlCol="0" anchor="ctr"/>
+          <a:lstStyle/>
+          <a:p>
+            <a:pPr indent="0" marL="0">
+              <a:buNone/>
+            </a:pPr>
+            <a:r>
+              <a:rPr lang="en-US" sz="3000" b="1" dirty="0">
+                <a:solidFill>
+                  <a:srgbClr val="4392F1"/>
+                </a:solidFill>
+                <a:latin typeface="Montserrat" pitchFamily="34" charset="0"/>
+                <a:ea typeface="Montserrat" pitchFamily="34" charset="-122"/>
+                <a:cs typeface="Montserrat" pitchFamily="34" charset="-120"/>
+              </a:rPr>
+              <a:t>Your privacy</a:t>
+            </a:r>
+            <a:endParaRPr lang="en-US" sz="3000" dirty="0"/>
+          </a:p>
+        </p:txBody>
+      </p:sp>
+      <p:sp>
+        <p:nvSpPr>
+          <p:cNvPr id="3" name="Shape 1"/>
+          <p:cNvSpPr/>
+          <p:nvPr/>
+        </p:nvSpPr>
+        <p:spPr>
+          <a:xfrm>
+            <a:off x="457200" y="1280160"/>
+            <a:ext cx="329184" cy="329184"/>
+          </a:xfrm>
+          <a:prstGeom prst="ellipse">
+            <a:avLst/>
+          </a:prstGeom>
+          <a:solidFill>
+            <a:srgbClr val="DCFF38"/>
+          </a:solidFill>
+          <a:ln w="12700">
+            <a:solidFill>
+              <a:srgbClr val="DCFF38"/>
+            </a:solidFill>
+            <a:prstDash val="solid"/>
+          </a:ln>
+        </p:spPr>
+      </p:sp>
+      <p:sp>
+        <p:nvSpPr>
+          <p:cNvPr id="4" name="Text 2"/>
+          <p:cNvSpPr txBox="1"/>
+          <p:nvPr/>
+        </p:nvSpPr>
+        <p:spPr>
+          <a:xfrm>
+            <a:off x="457200" y="1280160"/>
+            <a:ext cx="329184" cy="329184"/>
+          </a:xfrm>
+          <a:prstGeom prst="rect">
+            <a:avLst/>
+          </a:prstGeom>
+          <a:noFill/>
+          <a:ln/>
+        </p:spPr>
+        <p:txBody>
+          <a:bodyPr wrap="square" lIns="0" tIns="0" rIns="0" bIns="0" rtlCol="0" anchor="ctr"/>
+          <a:lstStyle/>
+          <a:p>
+            <a:pPr algn="ctr" indent="0" marL="0">
+              <a:buNone/>
+            </a:pPr>
+            <a:r>
+              <a:rPr lang="en-US" sz="1300" b="1" dirty="0">
+                <a:solidFill>
+                  <a:srgbClr val="00212B"/>
+                </a:solidFill>
+                <a:latin typeface="Montserrat" pitchFamily="34" charset="0"/>
+                <a:ea typeface="Montserrat" pitchFamily="34" charset="-122"/>
+                <a:cs typeface="Montserrat" pitchFamily="34" charset="-120"/>
+              </a:rPr>
+              <a:t>✓</a:t>
+            </a:r>
+            <a:endParaRPr lang="en-US" sz="1300" dirty="0"/>
+          </a:p>
+        </p:txBody>
+      </p:sp>
+      <p:sp>
+        <p:nvSpPr>
+          <p:cNvPr id="5" name="Text 3"/>
+          <p:cNvSpPr txBox="1"/>
+          <p:nvPr/>
+        </p:nvSpPr>
+        <p:spPr>
+          <a:xfrm>
+            <a:off x="960120" y="1234440"/>
+            <a:ext cx="4297680" cy="731520"/>
+          </a:xfrm>
+          <a:prstGeom prst="rect">
+            <a:avLst/>
+          </a:prstGeom>
+          <a:noFill/>
+          <a:ln/>
+        </p:spPr>
+        <p:txBody>
+          <a:bodyPr wrap="square" lIns="0" tIns="0" rIns="0" bIns="0" rtlCol="0" anchor="t"/>
+          <a:lstStyle/>
+          <a:p>
+            <a:pPr indent="0" marL="0">
+              <a:buNone/>
+            </a:pPr>
+            <a:r>
+              <a:rPr lang="en-US" sz="1300" dirty="0">
+                <a:solidFill>
+                  <a:srgbClr val="00212B"/>
+                </a:solidFill>
+                <a:latin typeface="Montserrat" pitchFamily="34" charset="0"/>
+                <a:ea typeface="Montserrat" pitchFamily="34" charset="-122"/>
+                <a:cs typeface="Montserrat" pitchFamily="34" charset="-120"/>
+              </a:rPr>
+              <a:t>Your conferences, recordings, photos and notes stay on this device unless you export or share them.</a:t>
+            </a:r>
+            <a:endParaRPr lang="en-US" sz="1300" dirty="0"/>
+          </a:p>
+        </p:txBody>
+      </p:sp>
+      <p:sp>
+        <p:nvSpPr>
+          <p:cNvPr id="6" name="Shape 4"/>
+          <p:cNvSpPr/>
+          <p:nvPr/>
+        </p:nvSpPr>
+        <p:spPr>
+          <a:xfrm>
+            <a:off x="457200" y="2103120"/>
+            <a:ext cx="329184" cy="329184"/>
+          </a:xfrm>
+          <a:prstGeom prst="ellipse">
+            <a:avLst/>
+          </a:prstGeom>
+          <a:solidFill>
+            <a:srgbClr val="DCFF38"/>
+          </a:solidFill>
+          <a:ln w="12700">
+            <a:solidFill>
+              <a:srgbClr val="DCFF38"/>
+            </a:solidFill>
+            <a:prstDash val="solid"/>
+          </a:ln>
+        </p:spPr>
+      </p:sp>
+      <p:sp>
+        <p:nvSpPr>
+          <p:cNvPr id="7" name="Text 5"/>
+          <p:cNvSpPr txBox="1"/>
+          <p:nvPr/>
+        </p:nvSpPr>
+        <p:spPr>
+          <a:xfrm>
+            <a:off x="457200" y="2103120"/>
+            <a:ext cx="329184" cy="329184"/>
+          </a:xfrm>
+          <a:prstGeom prst="rect">
+            <a:avLst/>
+          </a:prstGeom>
+          <a:noFill/>
+          <a:ln/>
+        </p:spPr>
+        <p:txBody>
+          <a:bodyPr wrap="square" lIns="0" tIns="0" rIns="0" bIns="0" rtlCol="0" anchor="ctr"/>
+          <a:lstStyle/>
+          <a:p>
+            <a:pPr algn="ctr" indent="0" marL="0">
+              <a:buNone/>
+            </a:pPr>
+            <a:r>
+              <a:rPr lang="en-US" sz="1300" b="1" dirty="0">
+                <a:solidFill>
+                  <a:srgbClr val="00212B"/>
+                </a:solidFill>
+                <a:latin typeface="Montserrat" pitchFamily="34" charset="0"/>
+                <a:ea typeface="Montserrat" pitchFamily="34" charset="-122"/>
+                <a:cs typeface="Montserrat" pitchFamily="34" charset="-120"/>
+              </a:rPr>
+              <a:t>✓</a:t>
+            </a:r>
+            <a:endParaRPr lang="en-US" sz="1300" dirty="0"/>
+          </a:p>
+        </p:txBody>
+      </p:sp>
+      <p:sp>
+        <p:nvSpPr>
+          <p:cNvPr id="8" name="Text 6"/>
+          <p:cNvSpPr txBox="1"/>
+          <p:nvPr/>
+        </p:nvSpPr>
+        <p:spPr>
+          <a:xfrm>
+            <a:off x="960120" y="2057400"/>
+            <a:ext cx="4297680" cy="731520"/>
+          </a:xfrm>
+          <a:prstGeom prst="rect">
+            <a:avLst/>
+          </a:prstGeom>
+          <a:noFill/>
+          <a:ln/>
+        </p:spPr>
+        <p:txBody>
+          <a:bodyPr wrap="square" lIns="0" tIns="0" rIns="0" bIns="0" rtlCol="0" anchor="t"/>
+          <a:lstStyle/>
+          <a:p>
+            <a:pPr indent="0" marL="0">
+              <a:buNone/>
+            </a:pPr>
+            <a:r>
+              <a:rPr lang="en-US" sz="1300" dirty="0">
+                <a:solidFill>
+                  <a:srgbClr val="00212B"/>
+                </a:solidFill>
+                <a:latin typeface="Montserrat" pitchFamily="34" charset="0"/>
+                <a:ea typeface="Montserrat" pitchFamily="34" charset="-122"/>
+                <a:cs typeface="Montserrat" pitchFamily="34" charset="-120"/>
+              </a:rPr>
+              <a:t>No account, no analytics, no adverts and no trackers.</a:t>
+            </a:r>
+            <a:endParaRPr lang="en-US" sz="1300" dirty="0"/>
+          </a:p>
+        </p:txBody>
+      </p:sp>
+      <p:sp>
+        <p:nvSpPr>
+          <p:cNvPr id="9" name="Shape 7"/>
+          <p:cNvSpPr/>
+          <p:nvPr/>
+        </p:nvSpPr>
+        <p:spPr>
+          <a:xfrm>
+            <a:off x="457200" y="2926080"/>
+            <a:ext cx="329184" cy="329184"/>
+          </a:xfrm>
+          <a:prstGeom prst="ellipse">
+            <a:avLst/>
+          </a:prstGeom>
+          <a:solidFill>
+            <a:srgbClr val="DCFF38"/>
+          </a:solidFill>
+          <a:ln w="12700">
+            <a:solidFill>
+              <a:srgbClr val="DCFF38"/>
+            </a:solidFill>
+            <a:prstDash val="solid"/>
+          </a:ln>
+        </p:spPr>
+      </p:sp>
+      <p:sp>
+        <p:nvSpPr>
+          <p:cNvPr id="10" name="Text 8"/>
+          <p:cNvSpPr txBox="1"/>
+          <p:nvPr/>
+        </p:nvSpPr>
+        <p:spPr>
+          <a:xfrm>
+            <a:off x="457200" y="2926080"/>
+            <a:ext cx="329184" cy="329184"/>
+          </a:xfrm>
+          <a:prstGeom prst="rect">
+            <a:avLst/>
+          </a:prstGeom>
+          <a:noFill/>
+          <a:ln/>
+        </p:spPr>
+        <p:txBody>
+          <a:bodyPr wrap="square" lIns="0" tIns="0" rIns="0" bIns="0" rtlCol="0" anchor="ctr"/>
+          <a:lstStyle/>
+          <a:p>
+            <a:pPr algn="ctr" indent="0" marL="0">
+              <a:buNone/>
+            </a:pPr>
+            <a:r>
+              <a:rPr lang="en-US" sz="1300" b="1" dirty="0">
+                <a:solidFill>
+                  <a:srgbClr val="00212B"/>
+                </a:solidFill>
+                <a:latin typeface="Montserrat" pitchFamily="34" charset="0"/>
+                <a:ea typeface="Montserrat" pitchFamily="34" charset="-122"/>
+                <a:cs typeface="Montserrat" pitchFamily="34" charset="-120"/>
+              </a:rPr>
+              <a:t>✓</a:t>
+            </a:r>
+            <a:endParaRPr lang="en-US" sz="1300" dirty="0"/>
+          </a:p>
+        </p:txBody>
+      </p:sp>
+      <p:sp>
+        <p:nvSpPr>
+          <p:cNvPr id="11" name="Text 9"/>
+          <p:cNvSpPr txBox="1"/>
+          <p:nvPr/>
+        </p:nvSpPr>
+        <p:spPr>
+          <a:xfrm>
+            <a:off x="960120" y="2880360"/>
+            <a:ext cx="4297680" cy="731520"/>
+          </a:xfrm>
+          <a:prstGeom prst="rect">
+            <a:avLst/>
+          </a:prstGeom>
+          <a:noFill/>
+          <a:ln/>
+        </p:spPr>
+        <p:txBody>
+          <a:bodyPr wrap="square" lIns="0" tIns="0" rIns="0" bIns="0" rtlCol="0" anchor="t"/>
+          <a:lstStyle/>
+          <a:p>
+            <a:pPr indent="0" marL="0">
+              <a:buNone/>
+            </a:pPr>
+            <a:r>
+              <a:rPr lang="en-US" sz="1300" dirty="0">
+                <a:solidFill>
+                  <a:srgbClr val="00212B"/>
+                </a:solidFill>
+                <a:latin typeface="Montserrat" pitchFamily="34" charset="0"/>
+                <a:ea typeface="Montserrat" pitchFamily="34" charset="-122"/>
+                <a:cs typeface="Montserrat" pitchFamily="34" charset="-120"/>
+              </a:rPr>
+              <a:t>Recording is always shown on screen. There is no hidden recording mode.</a:t>
+            </a:r>
+            <a:endParaRPr lang="en-US" sz="1300" dirty="0"/>
+          </a:p>
+        </p:txBody>
+      </p:sp>
+      <p:sp>
+        <p:nvSpPr>
+          <p:cNvPr id="12" name="Shape 10"/>
+          <p:cNvSpPr/>
+          <p:nvPr/>
+        </p:nvSpPr>
+        <p:spPr>
+          <a:xfrm>
+            <a:off x="457200" y="3749040"/>
+            <a:ext cx="329184" cy="329184"/>
+          </a:xfrm>
+          <a:prstGeom prst="ellipse">
+            <a:avLst/>
+          </a:prstGeom>
+          <a:solidFill>
+            <a:srgbClr val="DCFF38"/>
+          </a:solidFill>
+          <a:ln w="12700">
+            <a:solidFill>
+              <a:srgbClr val="DCFF38"/>
+            </a:solidFill>
+            <a:prstDash val="solid"/>
+          </a:ln>
+        </p:spPr>
+      </p:sp>
+      <p:sp>
+        <p:nvSpPr>
+          <p:cNvPr id="13" name="Text 11"/>
+          <p:cNvSpPr txBox="1"/>
+          <p:nvPr/>
+        </p:nvSpPr>
+        <p:spPr>
+          <a:xfrm>
+            <a:off x="457200" y="3749040"/>
+            <a:ext cx="329184" cy="329184"/>
+          </a:xfrm>
+          <a:prstGeom prst="rect">
+            <a:avLst/>
+          </a:prstGeom>
+          <a:noFill/>
+          <a:ln/>
+        </p:spPr>
+        <p:txBody>
+          <a:bodyPr wrap="square" lIns="0" tIns="0" rIns="0" bIns="0" rtlCol="0" anchor="ctr"/>
+          <a:lstStyle/>
+          <a:p>
+            <a:pPr algn="ctr" indent="0" marL="0">
+              <a:buNone/>
+            </a:pPr>
+            <a:r>
+              <a:rPr lang="en-US" sz="1300" b="1" dirty="0">
+                <a:solidFill>
+                  <a:srgbClr val="00212B"/>
+                </a:solidFill>
+                <a:latin typeface="Montserrat" pitchFamily="34" charset="0"/>
+                <a:ea typeface="Montserrat" pitchFamily="34" charset="-122"/>
+                <a:cs typeface="Montserrat" pitchFamily="34" charset="-120"/>
+              </a:rPr>
+              <a:t>✓</a:t>
+            </a:r>
+            <a:endParaRPr lang="en-US" sz="1300" dirty="0"/>
+          </a:p>
+        </p:txBody>
+      </p:sp>
+      <p:sp>
+        <p:nvSpPr>
+          <p:cNvPr id="14" name="Text 12"/>
+          <p:cNvSpPr txBox="1"/>
+          <p:nvPr/>
+        </p:nvSpPr>
+        <p:spPr>
+          <a:xfrm>
+            <a:off x="960120" y="3703320"/>
+            <a:ext cx="4297680" cy="731520"/>
+          </a:xfrm>
+          <a:prstGeom prst="rect">
+            <a:avLst/>
+          </a:prstGeom>
+          <a:noFill/>
+          <a:ln/>
+        </p:spPr>
+        <p:txBody>
+          <a:bodyPr wrap="square" lIns="0" tIns="0" rIns="0" bIns="0" rtlCol="0" anchor="t"/>
+          <a:lstStyle/>
+          <a:p>
+            <a:pPr indent="0" marL="0">
+              <a:buNone/>
+            </a:pPr>
+            <a:r>
+              <a:rPr lang="en-US" sz="1300" dirty="0">
+                <a:solidFill>
+                  <a:srgbClr val="00212B"/>
+                </a:solidFill>
+                <a:latin typeface="Montserrat" pitchFamily="34" charset="0"/>
+                <a:ea typeface="Montserrat" pitchFamily="34" charset="-122"/>
+                <a:cs typeface="Montserrat" pitchFamily="34" charset="-120"/>
+              </a:rPr>
+              <a:t>Turn on App lock under My conferences, menu, Settings, Privacy and app lock, to ask for your fingerprint, face or PIN.</a:t>
+            </a:r>
+            <a:endParaRPr lang="en-US" sz="1300" dirty="0"/>
+          </a:p>
+        </p:txBody>
+      </p:sp>
+      <p:sp>
+        <p:nvSpPr>
+          <p:cNvPr id="15" name="Shape 13"/>
+          <p:cNvSpPr/>
+          <p:nvPr/>
+        </p:nvSpPr>
+        <p:spPr>
+          <a:xfrm>
+            <a:off x="6748272" y="438912"/>
+            <a:ext cx="1876806" cy="4014216"/>
+          </a:xfrm>
+          <a:prstGeom prst="roundRect">
+            <a:avLst>
+              <a:gd name="adj" fmla="val 8770"/>
+            </a:avLst>
+          </a:prstGeom>
+          <a:solidFill>
+            <a:srgbClr val="00212B"/>
+          </a:solidFill>
+          <a:ln w="12700">
+            <a:solidFill>
+              <a:srgbClr val="00212B"/>
+            </a:solidFill>
+            <a:prstDash val="solid"/>
+          </a:ln>
+          <a:effectLst>
+            <a:outerShdw sx="100000" sy="100000" kx="0" ky="0" algn="bl" rotWithShape="0" blurRad="101600" dist="38100" dir="5400000">
+              <a:srgbClr val="000000">
+                <a:alpha val="18000"/>
+              </a:srgbClr>
+            </a:outerShdw>
+          </a:effectLst>
+        </p:spPr>
+      </p:sp>
+      <p:pic>
+        <p:nvPicPr>
+          <p:cNvPr id="16" name="Image 0" descr="Attenlume screen: privacy">    </p:cNvPr>
+          <p:cNvPicPr>
+            <a:picLocks noChangeAspect="1"/>
+          </p:cNvPicPr>
+          <p:nvPr/>
+        </p:nvPicPr>
+        <p:blipFill>
+          <a:blip r:embed="rId1"/>
+          <a:stretch>
+            <a:fillRect/>
+          </a:stretch>
+        </p:blipFill>
+        <p:spPr>
+          <a:xfrm>
+            <a:off x="6812280" y="502920"/>
+            <a:ext cx="1748790" cy="3886200"/>
+          </a:xfrm>
+          <a:prstGeom prst="rect">
+            <a:avLst/>
+          </a:prstGeom>
+        </p:spPr>
+      </p:pic>
+      <p:sp>
+        <p:nvSpPr>
+          <p:cNvPr id="25" name="Slide Number Placeholder 0"/>
+          <p:cNvSpPr>
+            <a:spLocks noGrp="1"/>
+          </p:cNvSpPr>
+          <p:nvPr>
+            <p:ph type="sldNum" sz="quarter" idx="4294967295"/>
+          </p:nvPr>
+        </p:nvSpPr>
+        <p:spPr>
+          <a:xfrm>
+            <a:off x="8321040" y="4754880"/>
+            <a:ext cx="365760" cy="274320"/>
+          </a:xfrm>
+          <a:prstGeom prst="rect">
+            <a:avLst/>
+          </a:prstGeom>
+          <a:extLst>
+            <a:ext uri="{C572A759-6A51-4108-AA02-DFA0A04FC94B}">
+              <ma14:wrappingTextBoxFlag xmlns:ma14="http://schemas.microsoft.com/office/mac/drawingml/2011/main" val="0"/>
+            </a:ext>
+          </a:extLst>
+        </p:spPr>
+        <p:txBody>
+          <a:bodyPr/>
+          <a:lstStyle>
+            <a:lvl1pPr>
+              <a:defRPr sz="900">
+                <a:solidFill>
+                  <a:srgbClr val="5B6B70"/>
+                </a:solidFill>
+                <a:latin typeface="Montserrat"/>
+                <a:ea typeface="Montserrat"/>
+                <a:cs typeface="Montserrat"/>
+              </a:defRPr>
+            </a:lvl1pPr>
+          </a:lstStyle>
+          <a:p>
+            <a:pPr algn="r"/>
+            <a:fld id="{F7021451-1387-4CA6-816F-3879F97B5CBC}" type="slidenum">
+              <a:rPr b="0" lang="en-US"/>
+              <a:t>20</a:t>
+            </a:fld>
+            <a:endParaRPr lang="en-US"/>
+          </a:p>
+        </p:txBody>
+      </p:sp>
+    </p:spTree>
+  </p:cSld>
+  <p:clrMapOvr>
+    <a:masterClrMapping/>
+  </p:clrMapOvr>
+</p:sld>
+</file>
+
+<file path=ppt/slides/slide21.xml><?xml version="1.0" encoding="utf-8"?>
+<p:sld xmlns:a="http://schemas.openxmlformats.org/drawingml/2006/main" xmlns:r="http://schemas.openxmlformats.org/officeDocument/2006/relationships" xmlns:p="http://schemas.openxmlformats.org/presentationml/2006/main">
+  <p:cSld name="Slide 21">
+    <p:spTree>
+      <p:nvGrpSpPr>
+        <p:cNvPr id="1" name=""/>
+        <p:cNvGrpSpPr/>
+        <p:nvPr/>
+      </p:nvGrpSpPr>
+      <p:grpSpPr>
+        <a:xfrm>
+          <a:off x="0" y="0"/>
+          <a:ext cx="0" cy="0"/>
+          <a:chOff x="0" y="0"/>
+          <a:chExt cx="0" cy="0"/>
+        </a:xfrm>
+      </p:grpSpPr>
+      <p:sp>
+        <p:nvSpPr>
+          <p:cNvPr id="2" name="Text 0"/>
+          <p:cNvSpPr txBox="1"/>
+          <p:nvPr/>
+        </p:nvSpPr>
+        <p:spPr>
+          <a:xfrm>
+            <a:off x="457200" y="411480"/>
+            <a:ext cx="8229600" cy="640080"/>
+          </a:xfrm>
+          <a:prstGeom prst="rect">
+            <a:avLst/>
+          </a:prstGeom>
+          <a:noFill/>
+          <a:ln/>
+        </p:spPr>
+        <p:txBody>
+          <a:bodyPr wrap="square" lIns="0" tIns="0" rIns="0" bIns="0" rtlCol="0" anchor="ctr"/>
+          <a:lstStyle/>
+          <a:p>
+            <a:pPr indent="0" marL="0">
+              <a:buNone/>
+            </a:pPr>
+            <a:r>
+              <a:rPr lang="en-US" sz="3000" b="1" dirty="0">
+                <a:solidFill>
+                  <a:srgbClr val="4392F1"/>
+                </a:solidFill>
+                <a:latin typeface="Montserrat" pitchFamily="34" charset="0"/>
+                <a:ea typeface="Montserrat" pitchFamily="34" charset="-122"/>
+                <a:cs typeface="Montserrat" pitchFamily="34" charset="-120"/>
+              </a:rPr>
+              <a:t>Good to know</a:t>
+            </a:r>
+            <a:endParaRPr lang="en-US" sz="3000" dirty="0"/>
+          </a:p>
+        </p:txBody>
+      </p:sp>
+      <p:sp>
+        <p:nvSpPr>
+          <p:cNvPr id="3" name="Shape 1"/>
+          <p:cNvSpPr/>
+          <p:nvPr/>
+        </p:nvSpPr>
+        <p:spPr>
+          <a:xfrm>
+            <a:off x="457200" y="1234440"/>
+            <a:ext cx="3977640" cy="1463040"/>
+          </a:xfrm>
+          <a:prstGeom prst="roundRect">
+            <a:avLst>
+              <a:gd name="adj" fmla="val 9375"/>
+            </a:avLst>
+          </a:prstGeom>
+          <a:solidFill>
+            <a:srgbClr val="EAF2FD"/>
+          </a:solidFill>
+          <a:ln w="12700">
+            <a:solidFill>
+              <a:srgbClr val="EAF2FD"/>
+            </a:solidFill>
+            <a:prstDash val="solid"/>
+          </a:ln>
+        </p:spPr>
+      </p:sp>
+      <p:sp>
+        <p:nvSpPr>
+          <p:cNvPr id="4" name="Text 2"/>
+          <p:cNvSpPr txBox="1"/>
+          <p:nvPr/>
+        </p:nvSpPr>
+        <p:spPr>
+          <a:xfrm>
+            <a:off x="685800" y="1417320"/>
+            <a:ext cx="3520440" cy="365760"/>
+          </a:xfrm>
+          <a:prstGeom prst="rect">
+            <a:avLst/>
+          </a:prstGeom>
+          <a:noFill/>
+          <a:ln/>
+        </p:spPr>
+        <p:txBody>
+          <a:bodyPr wrap="square" lIns="0" tIns="0" rIns="0" bIns="0" rtlCol="0" anchor="ctr"/>
+          <a:lstStyle/>
+          <a:p>
+            <a:pPr indent="0" marL="0">
+              <a:buNone/>
+            </a:pPr>
+            <a:r>
+              <a:rPr lang="en-US" sz="1600" b="1" dirty="0">
+                <a:solidFill>
+                  <a:srgbClr val="4392F1"/>
+                </a:solidFill>
+                <a:latin typeface="Montserrat" pitchFamily="34" charset="0"/>
+                <a:ea typeface="Montserrat" pitchFamily="34" charset="-122"/>
+                <a:cs typeface="Montserrat" pitchFamily="34" charset="-120"/>
+              </a:rPr>
+              <a:t>Ask before you record</a:t>
+            </a:r>
+            <a:endParaRPr lang="en-US" sz="1600" dirty="0"/>
+          </a:p>
+        </p:txBody>
+      </p:sp>
+      <p:sp>
+        <p:nvSpPr>
+          <p:cNvPr id="5" name="Text 3"/>
+          <p:cNvSpPr txBox="1"/>
+          <p:nvPr/>
+        </p:nvSpPr>
+        <p:spPr>
+          <a:xfrm>
+            <a:off x="685800" y="1828800"/>
+            <a:ext cx="3520440" cy="731520"/>
+          </a:xfrm>
+          <a:prstGeom prst="rect">
+            <a:avLst/>
+          </a:prstGeom>
+          <a:noFill/>
+          <a:ln/>
+        </p:spPr>
+        <p:txBody>
+          <a:bodyPr wrap="square" lIns="0" tIns="0" rIns="0" bIns="0" rtlCol="0" anchor="t"/>
+          <a:lstStyle/>
+          <a:p>
+            <a:pPr indent="0" marL="0">
+              <a:buNone/>
+            </a:pPr>
+            <a:r>
+              <a:rPr lang="en-US" sz="1300" dirty="0">
+                <a:solidFill>
+                  <a:srgbClr val="00212B"/>
+                </a:solidFill>
+                <a:latin typeface="Montserrat" pitchFamily="34" charset="0"/>
+                <a:ea typeface="Montserrat" pitchFamily="34" charset="-122"/>
+                <a:cs typeface="Montserrat" pitchFamily="34" charset="-120"/>
+              </a:rPr>
+              <a:t>Some events and speakers do not allow recording. Record only when permitted.</a:t>
+            </a:r>
+            <a:endParaRPr lang="en-US" sz="1300" dirty="0"/>
+          </a:p>
+        </p:txBody>
+      </p:sp>
+      <p:sp>
+        <p:nvSpPr>
+          <p:cNvPr id="6" name="Shape 4"/>
+          <p:cNvSpPr/>
+          <p:nvPr/>
+        </p:nvSpPr>
+        <p:spPr>
+          <a:xfrm>
+            <a:off x="4709160" y="1234440"/>
+            <a:ext cx="3977640" cy="1463040"/>
+          </a:xfrm>
+          <a:prstGeom prst="roundRect">
+            <a:avLst>
+              <a:gd name="adj" fmla="val 9375"/>
+            </a:avLst>
+          </a:prstGeom>
+          <a:solidFill>
+            <a:srgbClr val="EAF2FD"/>
+          </a:solidFill>
+          <a:ln w="12700">
+            <a:solidFill>
+              <a:srgbClr val="EAF2FD"/>
+            </a:solidFill>
+            <a:prstDash val="solid"/>
+          </a:ln>
+        </p:spPr>
+      </p:sp>
+      <p:sp>
+        <p:nvSpPr>
+          <p:cNvPr id="7" name="Text 5"/>
+          <p:cNvSpPr txBox="1"/>
+          <p:nvPr/>
+        </p:nvSpPr>
+        <p:spPr>
+          <a:xfrm>
+            <a:off x="4937760" y="1417320"/>
+            <a:ext cx="3520440" cy="365760"/>
+          </a:xfrm>
+          <a:prstGeom prst="rect">
+            <a:avLst/>
+          </a:prstGeom>
+          <a:noFill/>
+          <a:ln/>
+        </p:spPr>
+        <p:txBody>
+          <a:bodyPr wrap="square" lIns="0" tIns="0" rIns="0" bIns="0" rtlCol="0" anchor="ctr"/>
+          <a:lstStyle/>
+          <a:p>
+            <a:pPr indent="0" marL="0">
+              <a:buNone/>
+            </a:pPr>
+            <a:r>
+              <a:rPr lang="en-US" sz="1600" b="1" dirty="0">
+                <a:solidFill>
+                  <a:srgbClr val="4392F1"/>
+                </a:solidFill>
+                <a:latin typeface="Montserrat" pitchFamily="34" charset="0"/>
+                <a:ea typeface="Montserrat" pitchFamily="34" charset="-122"/>
+                <a:cs typeface="Montserrat" pitchFamily="34" charset="-120"/>
+              </a:rPr>
+              <a:t>Long sessions</a:t>
+            </a:r>
+            <a:endParaRPr lang="en-US" sz="1600" dirty="0"/>
+          </a:p>
+        </p:txBody>
+      </p:sp>
+      <p:sp>
+        <p:nvSpPr>
+          <p:cNvPr id="8" name="Text 6"/>
+          <p:cNvSpPr txBox="1"/>
+          <p:nvPr/>
+        </p:nvSpPr>
+        <p:spPr>
+          <a:xfrm>
+            <a:off x="4937760" y="1828800"/>
+            <a:ext cx="3520440" cy="731520"/>
+          </a:xfrm>
+          <a:prstGeom prst="rect">
+            <a:avLst/>
+          </a:prstGeom>
+          <a:noFill/>
+          <a:ln/>
+        </p:spPr>
+        <p:txBody>
+          <a:bodyPr wrap="square" lIns="0" tIns="0" rIns="0" bIns="0" rtlCol="0" anchor="t"/>
+          <a:lstStyle/>
+          <a:p>
+            <a:pPr indent="0" marL="0">
+              <a:buNone/>
+            </a:pPr>
+            <a:r>
+              <a:rPr lang="en-US" sz="1300" dirty="0">
+                <a:solidFill>
+                  <a:srgbClr val="00212B"/>
+                </a:solidFill>
+                <a:latin typeface="Montserrat" pitchFamily="34" charset="0"/>
+                <a:ea typeface="Montserrat" pitchFamily="34" charset="-122"/>
+                <a:cs typeface="Montserrat" pitchFamily="34" charset="-120"/>
+              </a:rPr>
+              <a:t>Attenlume checks in after two hours, after ten minutes of silence and when the battery is low. Change these in Settings.</a:t>
+            </a:r>
+            <a:endParaRPr lang="en-US" sz="1300" dirty="0"/>
+          </a:p>
+        </p:txBody>
+      </p:sp>
+      <p:sp>
+        <p:nvSpPr>
+          <p:cNvPr id="9" name="Shape 7"/>
+          <p:cNvSpPr/>
+          <p:nvPr/>
+        </p:nvSpPr>
+        <p:spPr>
+          <a:xfrm>
+            <a:off x="457200" y="2926080"/>
+            <a:ext cx="3977640" cy="1463040"/>
+          </a:xfrm>
+          <a:prstGeom prst="roundRect">
+            <a:avLst>
+              <a:gd name="adj" fmla="val 9375"/>
+            </a:avLst>
+          </a:prstGeom>
+          <a:solidFill>
+            <a:srgbClr val="EAF2FD"/>
+          </a:solidFill>
+          <a:ln w="12700">
+            <a:solidFill>
+              <a:srgbClr val="EAF2FD"/>
+            </a:solidFill>
+            <a:prstDash val="solid"/>
+          </a:ln>
+        </p:spPr>
+      </p:sp>
+      <p:sp>
+        <p:nvSpPr>
+          <p:cNvPr id="10" name="Text 8"/>
+          <p:cNvSpPr txBox="1"/>
+          <p:nvPr/>
+        </p:nvSpPr>
+        <p:spPr>
+          <a:xfrm>
+            <a:off x="685800" y="3108960"/>
+            <a:ext cx="3520440" cy="365760"/>
+          </a:xfrm>
+          <a:prstGeom prst="rect">
+            <a:avLst/>
+          </a:prstGeom>
+          <a:noFill/>
+          <a:ln/>
+        </p:spPr>
+        <p:txBody>
+          <a:bodyPr wrap="square" lIns="0" tIns="0" rIns="0" bIns="0" rtlCol="0" anchor="ctr"/>
+          <a:lstStyle/>
+          <a:p>
+            <a:pPr indent="0" marL="0">
+              <a:buNone/>
+            </a:pPr>
+            <a:r>
+              <a:rPr lang="en-US" sz="1600" b="1" dirty="0">
+                <a:solidFill>
+                  <a:srgbClr val="4392F1"/>
+                </a:solidFill>
+                <a:latin typeface="Montserrat" pitchFamily="34" charset="0"/>
+                <a:ea typeface="Montserrat" pitchFamily="34" charset="-122"/>
+                <a:cs typeface="Montserrat" pitchFamily="34" charset="-120"/>
+              </a:rPr>
+              <a:t>Updating</a:t>
+            </a:r>
+            <a:endParaRPr lang="en-US" sz="1600" dirty="0"/>
+          </a:p>
+        </p:txBody>
+      </p:sp>
+      <p:sp>
+        <p:nvSpPr>
+          <p:cNvPr id="11" name="Text 9"/>
+          <p:cNvSpPr txBox="1"/>
+          <p:nvPr/>
+        </p:nvSpPr>
+        <p:spPr>
+          <a:xfrm>
+            <a:off x="685800" y="3520440"/>
+            <a:ext cx="3520440" cy="731520"/>
+          </a:xfrm>
+          <a:prstGeom prst="rect">
+            <a:avLst/>
+          </a:prstGeom>
+          <a:noFill/>
+          <a:ln/>
+        </p:spPr>
+        <p:txBody>
+          <a:bodyPr wrap="square" lIns="0" tIns="0" rIns="0" bIns="0" rtlCol="0" anchor="t"/>
+          <a:lstStyle/>
+          <a:p>
+            <a:pPr indent="0" marL="0">
+              <a:buNone/>
+            </a:pPr>
+            <a:r>
+              <a:rPr lang="en-US" sz="1300" dirty="0">
+                <a:solidFill>
+                  <a:srgbClr val="00212B"/>
+                </a:solidFill>
+                <a:latin typeface="Montserrat" pitchFamily="34" charset="0"/>
+                <a:ea typeface="Montserrat" pitchFamily="34" charset="-122"/>
+                <a:cs typeface="Montserrat" pitchFamily="34" charset="-120"/>
+              </a:rPr>
+              <a:t>Installing a newer version keeps all your recordings.</a:t>
+            </a:r>
+            <a:endParaRPr lang="en-US" sz="1300" dirty="0"/>
+          </a:p>
+        </p:txBody>
+      </p:sp>
+      <p:sp>
+        <p:nvSpPr>
+          <p:cNvPr id="12" name="Shape 10"/>
+          <p:cNvSpPr/>
+          <p:nvPr/>
+        </p:nvSpPr>
+        <p:spPr>
+          <a:xfrm>
+            <a:off x="4709160" y="2926080"/>
+            <a:ext cx="3977640" cy="1463040"/>
+          </a:xfrm>
+          <a:prstGeom prst="roundRect">
+            <a:avLst>
+              <a:gd name="adj" fmla="val 9375"/>
+            </a:avLst>
+          </a:prstGeom>
+          <a:solidFill>
+            <a:srgbClr val="EAF2FD"/>
+          </a:solidFill>
+          <a:ln w="12700">
+            <a:solidFill>
+              <a:srgbClr val="EAF2FD"/>
+            </a:solidFill>
+            <a:prstDash val="solid"/>
+          </a:ln>
+        </p:spPr>
+      </p:sp>
+      <p:sp>
+        <p:nvSpPr>
+          <p:cNvPr id="13" name="Text 11"/>
+          <p:cNvSpPr txBox="1"/>
+          <p:nvPr/>
+        </p:nvSpPr>
+        <p:spPr>
+          <a:xfrm>
+            <a:off x="4937760" y="3108960"/>
+            <a:ext cx="3520440" cy="365760"/>
+          </a:xfrm>
+          <a:prstGeom prst="rect">
+            <a:avLst/>
+          </a:prstGeom>
+          <a:noFill/>
+          <a:ln/>
+        </p:spPr>
+        <p:txBody>
+          <a:bodyPr wrap="square" lIns="0" tIns="0" rIns="0" bIns="0" rtlCol="0" anchor="ctr"/>
+          <a:lstStyle/>
+          <a:p>
+            <a:pPr indent="0" marL="0">
+              <a:buNone/>
+            </a:pPr>
+            <a:r>
+              <a:rPr lang="en-US" sz="1600" b="1" dirty="0">
+                <a:solidFill>
+                  <a:srgbClr val="4392F1"/>
+                </a:solidFill>
+                <a:latin typeface="Montserrat" pitchFamily="34" charset="0"/>
+                <a:ea typeface="Montserrat" pitchFamily="34" charset="-122"/>
+                <a:cs typeface="Montserrat" pitchFamily="34" charset="-120"/>
+              </a:rPr>
+              <a:t>Before you uninstall</a:t>
+            </a:r>
+            <a:endParaRPr lang="en-US" sz="1600" dirty="0"/>
+          </a:p>
+        </p:txBody>
+      </p:sp>
+      <p:sp>
+        <p:nvSpPr>
+          <p:cNvPr id="14" name="Text 12"/>
+          <p:cNvSpPr txBox="1"/>
+          <p:nvPr/>
+        </p:nvSpPr>
+        <p:spPr>
+          <a:xfrm>
+            <a:off x="4937760" y="3520440"/>
+            <a:ext cx="3520440" cy="731520"/>
+          </a:xfrm>
+          <a:prstGeom prst="rect">
+            <a:avLst/>
+          </a:prstGeom>
+          <a:noFill/>
+          <a:ln/>
+        </p:spPr>
+        <p:txBody>
+          <a:bodyPr wrap="square" lIns="0" tIns="0" rIns="0" bIns="0" rtlCol="0" anchor="t"/>
+          <a:lstStyle/>
+          <a:p>
+            <a:pPr indent="0" marL="0">
+              <a:buNone/>
+            </a:pPr>
+            <a:r>
+              <a:rPr lang="en-US" sz="1300" dirty="0">
+                <a:solidFill>
+                  <a:srgbClr val="00212B"/>
+                </a:solidFill>
+                <a:latin typeface="Montserrat" pitchFamily="34" charset="0"/>
+                <a:ea typeface="Montserrat" pitchFamily="34" charset="-122"/>
+                <a:cs typeface="Montserrat" pitchFamily="34" charset="-120"/>
+              </a:rPr>
+              <a:t>Uninstalling deletes everything in the app. Export and share your conferences first.</a:t>
+            </a:r>
+            <a:endParaRPr lang="en-US" sz="1300" dirty="0"/>
+          </a:p>
+        </p:txBody>
+      </p:sp>
+      <p:sp>
+        <p:nvSpPr>
+          <p:cNvPr id="25" name="Slide Number Placeholder 0"/>
+          <p:cNvSpPr>
+            <a:spLocks noGrp="1"/>
+          </p:cNvSpPr>
+          <p:nvPr>
+            <p:ph type="sldNum" sz="quarter" idx="4294967295"/>
+          </p:nvPr>
+        </p:nvSpPr>
+        <p:spPr>
+          <a:xfrm>
+            <a:off x="8321040" y="4754880"/>
+            <a:ext cx="365760" cy="274320"/>
+          </a:xfrm>
+          <a:prstGeom prst="rect">
+            <a:avLst/>
+          </a:prstGeom>
+          <a:extLst>
+            <a:ext uri="{C572A759-6A51-4108-AA02-DFA0A04FC94B}">
+              <ma14:wrappingTextBoxFlag xmlns:ma14="http://schemas.microsoft.com/office/mac/drawingml/2011/main" val="0"/>
+            </a:ext>
+          </a:extLst>
+        </p:spPr>
+        <p:txBody>
+          <a:bodyPr/>
+          <a:lstStyle>
+            <a:lvl1pPr>
+              <a:defRPr sz="900">
+                <a:solidFill>
+                  <a:srgbClr val="5B6B70"/>
+                </a:solidFill>
+                <a:latin typeface="Montserrat"/>
+                <a:ea typeface="Montserrat"/>
+                <a:cs typeface="Montserrat"/>
+              </a:defRPr>
+            </a:lvl1pPr>
+          </a:lstStyle>
+          <a:p>
+            <a:pPr algn="r"/>
+            <a:fld id="{F7021451-1387-4CA6-816F-3879F97B5CBC}" type="slidenum">
+              <a:rPr b="0" lang="en-US"/>
+              <a:t>21</a:t>
+            </a:fld>
+            <a:endParaRPr lang="en-US"/>
+          </a:p>
+        </p:txBody>
+      </p:sp>
+    </p:spTree>
+  </p:cSld>
+  <p:clrMapOvr>
+    <a:masterClrMapping/>
+  </p:clrMapOvr>
+</p:sld>
+</file>
+
+<file path=ppt/slides/slide22.xml><?xml version="1.0" encoding="utf-8"?>
+<p:sld xmlns:a="http://schemas.openxmlformats.org/drawingml/2006/main" xmlns:r="http://schemas.openxmlformats.org/officeDocument/2006/relationships" xmlns:p="http://schemas.openxmlformats.org/presentationml/2006/main">
+  <p:cSld name="Slide 22">
+    <p:bg>
+      <p:bgPr>
+        <a:solidFill>
+          <a:srgbClr val="4392F1"/>
+        </a:solidFill>
+      </p:bgPr>
+    </p:bg>
+    <p:spTree>
+      <p:nvGrpSpPr>
+        <p:cNvPr id="1" name=""/>
+        <p:cNvGrpSpPr/>
+        <p:nvPr/>
+      </p:nvGrpSpPr>
+      <p:grpSpPr>
+        <a:xfrm>
+          <a:off x="0" y="0"/>
+          <a:ext cx="0" cy="0"/>
+          <a:chOff x="0" y="0"/>
+          <a:chExt cx="0" cy="0"/>
+        </a:xfrm>
+      </p:grpSpPr>
+      <p:sp>
+        <p:nvSpPr>
+          <p:cNvPr id="2" name="Shape 0"/>
+          <p:cNvSpPr/>
+          <p:nvPr/>
+        </p:nvSpPr>
+        <p:spPr>
+          <a:xfrm rot="1800000">
+            <a:off x="7863840" y="-320040"/>
+            <a:ext cx="2560320" cy="640080"/>
+          </a:xfrm>
+          <a:prstGeom prst="roundRect">
+            <a:avLst>
+              <a:gd name="adj" fmla="val 50000"/>
+            </a:avLst>
+          </a:prstGeom>
+          <a:solidFill>
+            <a:srgbClr val="FEFFF8"/>
+          </a:solidFill>
+          <a:ln w="12700">
+            <a:solidFill>
+              <a:srgbClr val="FEFFF8"/>
+            </a:solidFill>
+            <a:prstDash val="solid"/>
+          </a:ln>
+        </p:spPr>
+      </p:sp>
+      <p:sp>
+        <p:nvSpPr>
+          <p:cNvPr id="3" name="Shape 1"/>
+          <p:cNvSpPr/>
+          <p:nvPr/>
+        </p:nvSpPr>
+        <p:spPr>
+          <a:xfrm rot="1800000">
+            <a:off x="8229600" y="502920"/>
+            <a:ext cx="1463040" cy="411480"/>
+          </a:xfrm>
+          <a:prstGeom prst="roundRect">
+            <a:avLst>
+              <a:gd name="adj" fmla="val 48889"/>
+            </a:avLst>
+          </a:prstGeom>
+          <a:solidFill>
+            <a:srgbClr val="DCFF38"/>
+          </a:solidFill>
+          <a:ln w="12700">
+            <a:solidFill>
+              <a:srgbClr val="DCFF38"/>
+            </a:solidFill>
+            <a:prstDash val="solid"/>
+          </a:ln>
+        </p:spPr>
+      </p:sp>
+      <p:sp>
+        <p:nvSpPr>
+          <p:cNvPr id="4" name="Shape 2"/>
+          <p:cNvSpPr/>
+          <p:nvPr/>
+        </p:nvSpPr>
+        <p:spPr>
+          <a:xfrm rot="1800000">
+            <a:off x="-640080" y="4617720"/>
+            <a:ext cx="2011680" cy="502920"/>
+          </a:xfrm>
+          <a:prstGeom prst="roundRect">
+            <a:avLst>
+              <a:gd name="adj" fmla="val 49091"/>
+            </a:avLst>
+          </a:prstGeom>
+          <a:solidFill>
+            <a:srgbClr val="DCFF38"/>
+          </a:solidFill>
+          <a:ln w="12700">
+            <a:solidFill>
+              <a:srgbClr val="DCFF38"/>
+            </a:solidFill>
+            <a:prstDash val="solid"/>
+          </a:ln>
+        </p:spPr>
+      </p:sp>
+      <p:pic>
+        <p:nvPicPr>
+          <p:cNvPr id="5" name="Image 0" descr="Attenlume app icon">    </p:cNvPr>
+          <p:cNvPicPr>
+            <a:picLocks noChangeAspect="1"/>
+          </p:cNvPicPr>
+          <p:nvPr/>
+        </p:nvPicPr>
+        <p:blipFill>
+          <a:blip r:embed="rId1"/>
+          <a:stretch>
+            <a:fillRect/>
+          </a:stretch>
+        </p:blipFill>
+        <p:spPr>
+          <a:xfrm>
+            <a:off x="4023360" y="822960"/>
+            <a:ext cx="1097280" cy="1097280"/>
+          </a:xfrm>
+          <a:prstGeom prst="rect">
+            <a:avLst/>
+          </a:prstGeom>
+        </p:spPr>
+      </p:pic>
+      <p:sp>
+        <p:nvSpPr>
+          <p:cNvPr id="6" name="Text 3"/>
+          <p:cNvSpPr txBox="1"/>
+          <p:nvPr/>
+        </p:nvSpPr>
+        <p:spPr>
+          <a:xfrm>
+            <a:off x="685800" y="2148840"/>
+            <a:ext cx="7772400" cy="822960"/>
+          </a:xfrm>
+          <a:prstGeom prst="rect">
+            <a:avLst/>
+          </a:prstGeom>
+          <a:noFill/>
+          <a:ln/>
+        </p:spPr>
+        <p:txBody>
+          <a:bodyPr wrap="square" lIns="0" tIns="0" rIns="0" bIns="0" rtlCol="0" anchor="ctr"/>
+          <a:lstStyle/>
+          <a:p>
+            <a:pPr algn="ctr" indent="0" marL="0">
+              <a:buNone/>
+            </a:pPr>
+            <a:r>
+              <a:rPr lang="en-US" sz="3600" b="1" dirty="0">
+                <a:solidFill>
+                  <a:srgbClr val="FEFFF8"/>
+                </a:solidFill>
+                <a:latin typeface="Montserrat" pitchFamily="34" charset="0"/>
+                <a:ea typeface="Montserrat" pitchFamily="34" charset="-122"/>
+                <a:cs typeface="Montserrat" pitchFamily="34" charset="-120"/>
+              </a:rPr>
+              <a:t>Be present. Bring ideas to light.</a:t>
+            </a:r>
+            <a:endParaRPr lang="en-US" sz="3600" dirty="0"/>
+          </a:p>
+        </p:txBody>
+      </p:sp>
+      <p:sp>
+        <p:nvSpPr>
+          <p:cNvPr id="7" name="Text 4"/>
+          <p:cNvSpPr txBox="1"/>
+          <p:nvPr/>
+        </p:nvSpPr>
+        <p:spPr>
+          <a:xfrm>
+            <a:off x="1371600" y="3108960"/>
+            <a:ext cx="6400800" cy="731520"/>
+          </a:xfrm>
+          <a:prstGeom prst="rect">
+            <a:avLst/>
+          </a:prstGeom>
+          <a:noFill/>
+          <a:ln/>
+        </p:spPr>
+        <p:txBody>
+          <a:bodyPr wrap="square" lIns="0" tIns="0" rIns="0" bIns="0" rtlCol="0" anchor="ctr"/>
+          <a:lstStyle/>
+          <a:p>
+            <a:pPr algn="ctr" indent="0" marL="0">
+              <a:buNone/>
+            </a:pPr>
+            <a:r>
+              <a:rPr lang="en-US" sz="1500" dirty="0">
+                <a:solidFill>
+                  <a:srgbClr val="DCFF38"/>
+                </a:solidFill>
+                <a:latin typeface="Montserrat" pitchFamily="34" charset="0"/>
+                <a:ea typeface="Montserrat" pitchFamily="34" charset="-122"/>
+                <a:cs typeface="Montserrat" pitchFamily="34" charset="-120"/>
+              </a:rPr>
+              <a:t>Download for Android or Windows</a:t>
+            </a:r>
+            <a:endParaRPr lang="en-US" sz="1500" dirty="0"/>
+          </a:p>
+          <a:p>
+            <a:pPr algn="ctr" indent="0" marL="0">
+              <a:buNone/>
+            </a:pPr>
+            <a:r>
+              <a:rPr lang="en-US" sz="1500" b="1" dirty="0">
+                <a:solidFill>
+                  <a:srgbClr val="DCFF38"/>
+                </a:solidFill>
+                <a:latin typeface="Montserrat" pitchFamily="34" charset="0"/>
+                <a:ea typeface="Montserrat" pitchFamily="34" charset="-122"/>
+                <a:cs typeface="Montserrat" pitchFamily="34" charset="-120"/>
+              </a:rPr>
+              <a:t>github.com/SamsonOluwaseun/attenlume</a:t>
+            </a:r>
+            <a:endParaRPr lang="en-US" sz="1500" dirty="0"/>
+          </a:p>
+        </p:txBody>
+      </p:sp>
+      <p:sp>
+        <p:nvSpPr>
+          <p:cNvPr id="8" name="Text 5"/>
+          <p:cNvSpPr txBox="1"/>
+          <p:nvPr/>
+        </p:nvSpPr>
+        <p:spPr>
+          <a:xfrm>
+            <a:off x="1371600" y="4160520"/>
+            <a:ext cx="6400800" cy="274320"/>
+          </a:xfrm>
+          <a:prstGeom prst="rect">
+            <a:avLst/>
+          </a:prstGeom>
+          <a:noFill/>
+          <a:ln/>
+        </p:spPr>
+        <p:txBody>
+          <a:bodyPr wrap="square" lIns="0" tIns="0" rIns="0" bIns="0" rtlCol="0" anchor="ctr"/>
+          <a:lstStyle/>
+          <a:p>
+            <a:pPr algn="ctr" indent="0" marL="0">
+              <a:buNone/>
+            </a:pPr>
+            <a:r>
+              <a:rPr lang="en-US" sz="1100" dirty="0">
+                <a:solidFill>
+                  <a:srgbClr val="FEFFF8"/>
+                </a:solidFill>
+                <a:latin typeface="Montserrat" pitchFamily="34" charset="0"/>
+                <a:ea typeface="Montserrat" pitchFamily="34" charset="-122"/>
+                <a:cs typeface="Montserrat" pitchFamily="34" charset="-120"/>
+              </a:rPr>
+              <a:t>Samlytics Data Services</a:t>
+            </a:r>
+            <a:endParaRPr lang="en-US" sz="1100" dirty="0"/>
           </a:p>
         </p:txBody>
       </p:sp>
@@ -7194,7 +8840,7 @@
         <p:spPr>
           <a:xfrm>
             <a:off x="685800" y="2240280"/>
-            <a:ext cx="4754880" cy="731520"/>
+            <a:ext cx="5669280" cy="731520"/>
           </a:xfrm>
           <a:prstGeom prst="rect">
             <a:avLst/>
@@ -8155,7 +9801,7 @@
         <p:spPr>
           <a:xfrm>
             <a:off x="685800" y="2240280"/>
-            <a:ext cx="4754880" cy="731520"/>
+            <a:ext cx="5669280" cy="731520"/>
           </a:xfrm>
           <a:prstGeom prst="rect">
             <a:avLst/>

</xml_diff>

<commit_message>
Add the Samlytics logo to the quick guide; hide Manage models
- Samlytics Data Services logo at the top of the in-app quick guide
  (cream plate in dark theme), in every PDF page footer and the cover,
  and on every slide of the PowerPoint.
- Storage Manager: Models size and Manage models hidden until offline
  models arrive in Phase 2 (P2-08).

Co-Authored-By: Claude Opus 5.5 <noreply@anthropic.com>
</commit_message>
<xml_diff>
--- a/docs/user-guide/Attenlume-Quick-Guide.pptx
+++ b/docs/user-guide/Attenlume-Quick-Guide.pptx
@@ -128,20 +128,20 @@
   <p:extLst>
     <p:ext uri="{521415D9-36F7-43E2-AB2F-B90AF26B5E84}">
       <p14:sectionLst xmlns:p14="http://schemas.microsoft.com/office/powerpoint/2010/main">
-        <p14:section name="Welcome" id="{9040d4ae-c569-953d-c116-ba2f363b1cd7}">
+        <p14:section name="Welcome" id="{37a5cae2-08ab-586b-79c4-d2d481e0fbef}">
           <p14:sldIdLst>
             <p14:sldId id="256"/>
             <p14:sldId id="257"/>
           </p14:sldIdLst>
         </p14:section>
-        <p14:section name="Set up" id="{fc189cd2-c087-9a39-d885-fbb0405cb25d}">
+        <p14:section name="Set up" id="{612a8090-59a4-bb1c-1c49-44ae8acb0617}">
           <p14:sldIdLst>
             <p14:sldId id="258"/>
             <p14:sldId id="259"/>
             <p14:sldId id="260"/>
           </p14:sldIdLst>
         </p14:section>
-        <p14:section name="Capture" id="{f7da14c1-628a-7c89-81e2-53804dceb1ac}">
+        <p14:section name="Capture" id="{1f86e02c-a676-63be-7cd5-f3a99b8c953b}">
           <p14:sldIdLst>
             <p14:sldId id="261"/>
             <p14:sldId id="262"/>
@@ -149,21 +149,21 @@
             <p14:sldId id="264"/>
           </p14:sldIdLst>
         </p14:section>
-        <p14:section name="Review" id="{f1b7867d-c866-0e9e-fdbf-15ed796f436b}">
+        <p14:section name="Review" id="{32fb4325-fa0c-afca-2a2d-b4689f1a049d}">
           <p14:sldIdLst>
             <p14:sldId id="265"/>
             <p14:sldId id="266"/>
             <p14:sldId id="267"/>
           </p14:sldIdLst>
         </p14:section>
-        <p14:section name="Export and share" id="{225b8c21-0cdb-0436-e4e6-78d3c0b6d355}">
+        <p14:section name="Export and share" id="{a610766a-ac81-d419-e33c-7148cd06849d}">
           <p14:sldIdLst>
             <p14:sldId id="268"/>
             <p14:sldId id="269"/>
             <p14:sldId id="270"/>
           </p14:sldIdLst>
         </p14:section>
-        <p14:section name="Settings and storage" id="{5d8ca69c-9b3a-5231-b711-2116783199ca}">
+        <p14:section name="Settings and storage" id="{c540d606-9ab9-df69-5d2b-47c621175a45}">
           <p14:sldIdLst>
             <p14:sldId id="271"/>
             <p14:sldId id="272"/>
@@ -171,7 +171,7 @@
             <p14:sldId id="274"/>
           </p14:sldIdLst>
         </p14:section>
-        <p14:section name="Privacy and tips" id="{5e2d1063-5654-51f9-3585-4713a436adf2}">
+        <p14:section name="Privacy and tips" id="{ebcb44fc-f97f-406a-993b-109f4d688908}">
           <p14:sldIdLst>
             <p14:sldId id="275"/>
             <p14:sldId id="276"/>
@@ -2565,6 +2565,30 @@
           </a:p>
         </p:txBody>
       </p:sp>
+      <p:pic>
+        <p:nvPicPr>
+          <p:cNvPr id="3" name="Image 0" descr="Samlytics Data Services">    </p:cNvPr>
+          <p:cNvPicPr>
+            <a:picLocks noChangeAspect="1"/>
+          </p:cNvPicPr>
+          <p:nvPr/>
+        </p:nvPicPr>
+        <p:blipFill>
+          <a:blip r:embed="rId1"/>
+          <a:stretch>
+            <a:fillRect/>
+          </a:stretch>
+        </p:blipFill>
+        <p:spPr>
+          <a:xfrm>
+            <a:off x="6995160" y="4745736"/>
+            <a:ext cx="1118795" cy="237744"/>
+          </a:xfrm>
+          <a:prstGeom prst="rect">
+            <a:avLst/>
+          </a:prstGeom>
+        </p:spPr>
+      </p:pic>
       <p:sp>
         <p:nvSpPr>
           <p:cNvPr id="25" name="Slide Number Placeholder 0"/>
@@ -3054,46 +3078,34 @@
       </p:sp>
       <p:sp>
         <p:nvSpPr>
-          <p:cNvPr id="5" name="Text 3"/>
-          <p:cNvSpPr txBox="1"/>
-          <p:nvPr/>
-        </p:nvSpPr>
-        <p:spPr>
-          <a:xfrm>
-            <a:off x="457200" y="320040"/>
-            <a:ext cx="4572000" cy="274320"/>
-          </a:xfrm>
-          <a:prstGeom prst="rect">
-            <a:avLst/>
-          </a:prstGeom>
-          <a:noFill/>
-          <a:ln/>
-        </p:spPr>
-        <p:txBody>
-          <a:bodyPr wrap="square" lIns="0" tIns="0" rIns="0" bIns="0" rtlCol="0" anchor="ctr"/>
-          <a:lstStyle/>
-          <a:p>
-            <a:pPr indent="0" marL="0">
-              <a:buNone/>
-            </a:pPr>
-            <a:r>
-              <a:rPr lang="en-US" sz="1100" dirty="0">
-                <a:solidFill>
-                  <a:srgbClr val="FEFFF8"/>
-                </a:solidFill>
-                <a:latin typeface="Montserrat" pitchFamily="34" charset="0"/>
-                <a:ea typeface="Montserrat" pitchFamily="34" charset="-122"/>
-                <a:cs typeface="Montserrat" pitchFamily="34" charset="-120"/>
-              </a:rPr>
-              <a:t>Samlytics Data Services</a:t>
-            </a:r>
-            <a:endParaRPr lang="en-US" sz="1100" dirty="0"/>
-          </a:p>
-        </p:txBody>
+          <p:cNvPr id="5" name="Shape 3"/>
+          <p:cNvSpPr/>
+          <p:nvPr/>
+        </p:nvSpPr>
+        <p:spPr>
+          <a:xfrm>
+            <a:off x="457200" y="274320"/>
+            <a:ext cx="1920240" cy="552069"/>
+          </a:xfrm>
+          <a:prstGeom prst="roundRect">
+            <a:avLst>
+              <a:gd name="adj" fmla="val 13251"/>
+            </a:avLst>
+          </a:prstGeom>
+          <a:solidFill>
+            <a:srgbClr val="FEFFF8"/>
+          </a:solidFill>
+          <a:ln w="12700">
+            <a:solidFill>
+              <a:srgbClr val="FEFFF8"/>
+            </a:solidFill>
+            <a:prstDash val="solid"/>
+          </a:ln>
+        </p:spPr>
       </p:sp>
       <p:pic>
         <p:nvPicPr>
-          <p:cNvPr id="6" name="Image 0" descr="Attenlume app icon">    </p:cNvPr>
+          <p:cNvPr id="6" name="Image 0" descr="Samlytics Data Services">    </p:cNvPr>
           <p:cNvPicPr>
             <a:picLocks noChangeAspect="1"/>
           </p:cNvPicPr>
@@ -3107,6 +3119,30 @@
         </p:blipFill>
         <p:spPr>
           <a:xfrm>
+            <a:off x="548640" y="365760"/>
+            <a:ext cx="1737360" cy="369189"/>
+          </a:xfrm>
+          <a:prstGeom prst="rect">
+            <a:avLst/>
+          </a:prstGeom>
+        </p:spPr>
+      </p:pic>
+      <p:pic>
+        <p:nvPicPr>
+          <p:cNvPr id="7" name="Image 1" descr="Attenlume app icon">    </p:cNvPr>
+          <p:cNvPicPr>
+            <a:picLocks noChangeAspect="1"/>
+          </p:cNvPicPr>
+          <p:nvPr/>
+        </p:nvPicPr>
+        <p:blipFill>
+          <a:blip r:embed="rId2"/>
+          <a:stretch>
+            <a:fillRect/>
+          </a:stretch>
+        </p:blipFill>
+        <p:spPr>
+          <a:xfrm>
             <a:off x="3977640" y="868680"/>
             <a:ext cx="1188720" cy="1188720"/>
           </a:xfrm>
@@ -3117,7 +3153,7 @@
       </p:pic>
       <p:sp>
         <p:nvSpPr>
-          <p:cNvPr id="7" name="Text 4"/>
+          <p:cNvPr id="8" name="Text 4"/>
           <p:cNvSpPr txBox="1"/>
           <p:nvPr/>
         </p:nvSpPr>
@@ -3156,7 +3192,7 @@
       </p:sp>
       <p:sp>
         <p:nvSpPr>
-          <p:cNvPr id="8" name="Text 5"/>
+          <p:cNvPr id="9" name="Text 5"/>
           <p:cNvSpPr txBox="1"/>
           <p:nvPr/>
         </p:nvSpPr>
@@ -3195,7 +3231,7 @@
       </p:sp>
       <p:sp>
         <p:nvSpPr>
-          <p:cNvPr id="9" name="Text 6"/>
+          <p:cNvPr id="10" name="Text 6"/>
           <p:cNvSpPr txBox="1"/>
           <p:nvPr/>
         </p:nvSpPr>
@@ -3320,7 +3356,58 @@
       </p:sp>
       <p:sp>
         <p:nvSpPr>
-          <p:cNvPr id="4" name="Text 2"/>
+          <p:cNvPr id="4" name="Shape 2"/>
+          <p:cNvSpPr/>
+          <p:nvPr/>
+        </p:nvSpPr>
+        <p:spPr>
+          <a:xfrm>
+            <a:off x="685800" y="411480"/>
+            <a:ext cx="1554480" cy="474345"/>
+          </a:xfrm>
+          <a:prstGeom prst="roundRect">
+            <a:avLst>
+              <a:gd name="adj" fmla="val 15422"/>
+            </a:avLst>
+          </a:prstGeom>
+          <a:solidFill>
+            <a:srgbClr val="FEFFF8"/>
+          </a:solidFill>
+          <a:ln w="12700">
+            <a:solidFill>
+              <a:srgbClr val="FEFFF8"/>
+            </a:solidFill>
+            <a:prstDash val="solid"/>
+          </a:ln>
+        </p:spPr>
+      </p:sp>
+      <p:pic>
+        <p:nvPicPr>
+          <p:cNvPr id="5" name="Image 0" descr="Samlytics Data Services">    </p:cNvPr>
+          <p:cNvPicPr>
+            <a:picLocks noChangeAspect="1"/>
+          </p:cNvPicPr>
+          <p:nvPr/>
+        </p:nvPicPr>
+        <p:blipFill>
+          <a:blip r:embed="rId1"/>
+          <a:stretch>
+            <a:fillRect/>
+          </a:stretch>
+        </p:blipFill>
+        <p:spPr>
+          <a:xfrm>
+            <a:off x="777240" y="502920"/>
+            <a:ext cx="1371600" cy="291465"/>
+          </a:xfrm>
+          <a:prstGeom prst="rect">
+            <a:avLst/>
+          </a:prstGeom>
+        </p:spPr>
+      </p:pic>
+      <p:sp>
+        <p:nvSpPr>
+          <p:cNvPr id="6" name="Text 3"/>
           <p:cNvSpPr txBox="1"/>
           <p:nvPr/>
         </p:nvSpPr>
@@ -3359,7 +3446,7 @@
       </p:sp>
       <p:sp>
         <p:nvSpPr>
-          <p:cNvPr id="5" name="Text 3"/>
+          <p:cNvPr id="7" name="Text 4"/>
           <p:cNvSpPr txBox="1"/>
           <p:nvPr/>
         </p:nvSpPr>
@@ -3398,7 +3485,7 @@
       </p:sp>
       <p:sp>
         <p:nvSpPr>
-          <p:cNvPr id="6" name="Text 4"/>
+          <p:cNvPr id="8" name="Text 5"/>
           <p:cNvSpPr txBox="1"/>
           <p:nvPr/>
         </p:nvSpPr>
@@ -3437,7 +3524,7 @@
       </p:sp>
       <p:sp>
         <p:nvSpPr>
-          <p:cNvPr id="7" name="Shape 5"/>
+          <p:cNvPr id="9" name="Shape 6"/>
           <p:cNvSpPr/>
           <p:nvPr/>
         </p:nvSpPr>
@@ -3471,14 +3558,14 @@
       </p:sp>
       <p:pic>
         <p:nvPicPr>
-          <p:cNvPr id="8" name="Image 0" descr="Attenlume screen: activity details">    </p:cNvPr>
+          <p:cNvPr id="10" name="Image 1" descr="Attenlume screen: activity details">    </p:cNvPr>
           <p:cNvPicPr>
             <a:picLocks noChangeAspect="1"/>
           </p:cNvPicPr>
           <p:nvPr/>
         </p:nvPicPr>
         <p:blipFill>
-          <a:blip r:embed="rId1"/>
+          <a:blip r:embed="rId2"/>
           <a:stretch>
             <a:fillRect/>
           </a:stretch>
@@ -4281,7 +4368,58 @@
       </p:sp>
       <p:sp>
         <p:nvSpPr>
-          <p:cNvPr id="4" name="Text 2"/>
+          <p:cNvPr id="4" name="Shape 2"/>
+          <p:cNvSpPr/>
+          <p:nvPr/>
+        </p:nvSpPr>
+        <p:spPr>
+          <a:xfrm>
+            <a:off x="685800" y="411480"/>
+            <a:ext cx="1554480" cy="474345"/>
+          </a:xfrm>
+          <a:prstGeom prst="roundRect">
+            <a:avLst>
+              <a:gd name="adj" fmla="val 15422"/>
+            </a:avLst>
+          </a:prstGeom>
+          <a:solidFill>
+            <a:srgbClr val="FEFFF8"/>
+          </a:solidFill>
+          <a:ln w="12700">
+            <a:solidFill>
+              <a:srgbClr val="FEFFF8"/>
+            </a:solidFill>
+            <a:prstDash val="solid"/>
+          </a:ln>
+        </p:spPr>
+      </p:sp>
+      <p:pic>
+        <p:nvPicPr>
+          <p:cNvPr id="5" name="Image 0" descr="Samlytics Data Services">    </p:cNvPr>
+          <p:cNvPicPr>
+            <a:picLocks noChangeAspect="1"/>
+          </p:cNvPicPr>
+          <p:nvPr/>
+        </p:nvPicPr>
+        <p:blipFill>
+          <a:blip r:embed="rId1"/>
+          <a:stretch>
+            <a:fillRect/>
+          </a:stretch>
+        </p:blipFill>
+        <p:spPr>
+          <a:xfrm>
+            <a:off x="777240" y="502920"/>
+            <a:ext cx="1371600" cy="291465"/>
+          </a:xfrm>
+          <a:prstGeom prst="rect">
+            <a:avLst/>
+          </a:prstGeom>
+        </p:spPr>
+      </p:pic>
+      <p:sp>
+        <p:nvSpPr>
+          <p:cNvPr id="6" name="Text 3"/>
           <p:cNvSpPr txBox="1"/>
           <p:nvPr/>
         </p:nvSpPr>
@@ -4320,7 +4458,7 @@
       </p:sp>
       <p:sp>
         <p:nvSpPr>
-          <p:cNvPr id="5" name="Text 3"/>
+          <p:cNvPr id="7" name="Text 4"/>
           <p:cNvSpPr txBox="1"/>
           <p:nvPr/>
         </p:nvSpPr>
@@ -4359,7 +4497,7 @@
       </p:sp>
       <p:sp>
         <p:nvSpPr>
-          <p:cNvPr id="6" name="Text 4"/>
+          <p:cNvPr id="8" name="Text 5"/>
           <p:cNvSpPr txBox="1"/>
           <p:nvPr/>
         </p:nvSpPr>
@@ -4398,7 +4536,7 @@
       </p:sp>
       <p:sp>
         <p:nvSpPr>
-          <p:cNvPr id="7" name="Shape 5"/>
+          <p:cNvPr id="9" name="Shape 6"/>
           <p:cNvSpPr/>
           <p:nvPr/>
         </p:nvSpPr>
@@ -4432,14 +4570,14 @@
       </p:sp>
       <p:pic>
         <p:nvPicPr>
-          <p:cNvPr id="8" name="Image 0" descr="Attenlume screen: check before export">    </p:cNvPr>
+          <p:cNvPr id="10" name="Image 1" descr="Attenlume screen: check before export">    </p:cNvPr>
           <p:cNvPicPr>
             <a:picLocks noChangeAspect="1"/>
           </p:cNvPicPr>
           <p:nvPr/>
         </p:nvPicPr>
         <p:blipFill>
-          <a:blip r:embed="rId1"/>
+          <a:blip r:embed="rId2"/>
           <a:stretch>
             <a:fillRect/>
           </a:stretch>
@@ -5300,7 +5438,58 @@
       </p:sp>
       <p:sp>
         <p:nvSpPr>
-          <p:cNvPr id="4" name="Text 2"/>
+          <p:cNvPr id="4" name="Shape 2"/>
+          <p:cNvSpPr/>
+          <p:nvPr/>
+        </p:nvSpPr>
+        <p:spPr>
+          <a:xfrm>
+            <a:off x="685800" y="411480"/>
+            <a:ext cx="1554480" cy="474345"/>
+          </a:xfrm>
+          <a:prstGeom prst="roundRect">
+            <a:avLst>
+              <a:gd name="adj" fmla="val 15422"/>
+            </a:avLst>
+          </a:prstGeom>
+          <a:solidFill>
+            <a:srgbClr val="FEFFF8"/>
+          </a:solidFill>
+          <a:ln w="12700">
+            <a:solidFill>
+              <a:srgbClr val="FEFFF8"/>
+            </a:solidFill>
+            <a:prstDash val="solid"/>
+          </a:ln>
+        </p:spPr>
+      </p:sp>
+      <p:pic>
+        <p:nvPicPr>
+          <p:cNvPr id="5" name="Image 0" descr="Samlytics Data Services">    </p:cNvPr>
+          <p:cNvPicPr>
+            <a:picLocks noChangeAspect="1"/>
+          </p:cNvPicPr>
+          <p:nvPr/>
+        </p:nvPicPr>
+        <p:blipFill>
+          <a:blip r:embed="rId1"/>
+          <a:stretch>
+            <a:fillRect/>
+          </a:stretch>
+        </p:blipFill>
+        <p:spPr>
+          <a:xfrm>
+            <a:off x="777240" y="502920"/>
+            <a:ext cx="1371600" cy="291465"/>
+          </a:xfrm>
+          <a:prstGeom prst="rect">
+            <a:avLst/>
+          </a:prstGeom>
+        </p:spPr>
+      </p:pic>
+      <p:sp>
+        <p:nvSpPr>
+          <p:cNvPr id="6" name="Text 3"/>
           <p:cNvSpPr txBox="1"/>
           <p:nvPr/>
         </p:nvSpPr>
@@ -5339,7 +5528,7 @@
       </p:sp>
       <p:sp>
         <p:nvSpPr>
-          <p:cNvPr id="5" name="Text 3"/>
+          <p:cNvPr id="7" name="Text 4"/>
           <p:cNvSpPr txBox="1"/>
           <p:nvPr/>
         </p:nvSpPr>
@@ -5378,7 +5567,7 @@
       </p:sp>
       <p:sp>
         <p:nvSpPr>
-          <p:cNvPr id="6" name="Text 4"/>
+          <p:cNvPr id="8" name="Text 5"/>
           <p:cNvSpPr txBox="1"/>
           <p:nvPr/>
         </p:nvSpPr>
@@ -5417,7 +5606,7 @@
       </p:sp>
       <p:sp>
         <p:nvSpPr>
-          <p:cNvPr id="7" name="Shape 5"/>
+          <p:cNvPr id="9" name="Shape 6"/>
           <p:cNvSpPr/>
           <p:nvPr/>
         </p:nvSpPr>
@@ -5451,14 +5640,14 @@
       </p:sp>
       <p:pic>
         <p:nvPicPr>
-          <p:cNvPr id="8" name="Image 0" descr="Attenlume screen: settings">    </p:cNvPr>
+          <p:cNvPr id="10" name="Image 1" descr="Attenlume screen: settings">    </p:cNvPr>
           <p:cNvPicPr>
             <a:picLocks noChangeAspect="1"/>
           </p:cNvPicPr>
           <p:nvPr/>
         </p:nvPicPr>
         <p:blipFill>
-          <a:blip r:embed="rId1"/>
+          <a:blip r:embed="rId2"/>
           <a:stretch>
             <a:fillRect/>
           </a:stretch>
@@ -8669,43 +8858,55 @@
       </p:sp>
       <p:sp>
         <p:nvSpPr>
-          <p:cNvPr id="8" name="Text 5"/>
-          <p:cNvSpPr txBox="1"/>
-          <p:nvPr/>
-        </p:nvSpPr>
-        <p:spPr>
-          <a:xfrm>
-            <a:off x="1371600" y="4160520"/>
-            <a:ext cx="6400800" cy="274320"/>
-          </a:xfrm>
-          <a:prstGeom prst="rect">
-            <a:avLst/>
-          </a:prstGeom>
-          <a:noFill/>
-          <a:ln/>
-        </p:spPr>
-        <p:txBody>
-          <a:bodyPr wrap="square" lIns="0" tIns="0" rIns="0" bIns="0" rtlCol="0" anchor="ctr"/>
-          <a:lstStyle/>
-          <a:p>
-            <a:pPr algn="ctr" indent="0" marL="0">
-              <a:buNone/>
-            </a:pPr>
-            <a:r>
-              <a:rPr lang="en-US" sz="1100" dirty="0">
-                <a:solidFill>
-                  <a:srgbClr val="FEFFF8"/>
-                </a:solidFill>
-                <a:latin typeface="Montserrat" pitchFamily="34" charset="0"/>
-                <a:ea typeface="Montserrat" pitchFamily="34" charset="-122"/>
-                <a:cs typeface="Montserrat" pitchFamily="34" charset="-120"/>
-              </a:rPr>
-              <a:t>Samlytics Data Services</a:t>
-            </a:r>
-            <a:endParaRPr lang="en-US" sz="1100" dirty="0"/>
-          </a:p>
-        </p:txBody>
-      </p:sp>
+          <p:cNvPr id="8" name="Shape 5"/>
+          <p:cNvSpPr/>
+          <p:nvPr/>
+        </p:nvSpPr>
+        <p:spPr>
+          <a:xfrm>
+            <a:off x="3474720" y="4023360"/>
+            <a:ext cx="2194560" cy="610362"/>
+          </a:xfrm>
+          <a:prstGeom prst="roundRect">
+            <a:avLst>
+              <a:gd name="adj" fmla="val 11985"/>
+            </a:avLst>
+          </a:prstGeom>
+          <a:solidFill>
+            <a:srgbClr val="FEFFF8"/>
+          </a:solidFill>
+          <a:ln w="12700">
+            <a:solidFill>
+              <a:srgbClr val="FEFFF8"/>
+            </a:solidFill>
+            <a:prstDash val="solid"/>
+          </a:ln>
+        </p:spPr>
+      </p:sp>
+      <p:pic>
+        <p:nvPicPr>
+          <p:cNvPr id="9" name="Image 1" descr="Samlytics Data Services">    </p:cNvPr>
+          <p:cNvPicPr>
+            <a:picLocks noChangeAspect="1"/>
+          </p:cNvPicPr>
+          <p:nvPr/>
+        </p:nvPicPr>
+        <p:blipFill>
+          <a:blip r:embed="rId2"/>
+          <a:stretch>
+            <a:fillRect/>
+          </a:stretch>
+        </p:blipFill>
+        <p:spPr>
+          <a:xfrm>
+            <a:off x="3566160" y="4114800"/>
+            <a:ext cx="2011680" cy="427482"/>
+          </a:xfrm>
+          <a:prstGeom prst="rect">
+            <a:avLst/>
+          </a:prstGeom>
+        </p:spPr>
+      </p:pic>
     </p:spTree>
   </p:cSld>
   <p:clrMapOvr>
@@ -8794,7 +8995,58 @@
       </p:sp>
       <p:sp>
         <p:nvSpPr>
-          <p:cNvPr id="4" name="Text 2"/>
+          <p:cNvPr id="4" name="Shape 2"/>
+          <p:cNvSpPr/>
+          <p:nvPr/>
+        </p:nvSpPr>
+        <p:spPr>
+          <a:xfrm>
+            <a:off x="685800" y="411480"/>
+            <a:ext cx="1554480" cy="474345"/>
+          </a:xfrm>
+          <a:prstGeom prst="roundRect">
+            <a:avLst>
+              <a:gd name="adj" fmla="val 15422"/>
+            </a:avLst>
+          </a:prstGeom>
+          <a:solidFill>
+            <a:srgbClr val="FEFFF8"/>
+          </a:solidFill>
+          <a:ln w="12700">
+            <a:solidFill>
+              <a:srgbClr val="FEFFF8"/>
+            </a:solidFill>
+            <a:prstDash val="solid"/>
+          </a:ln>
+        </p:spPr>
+      </p:sp>
+      <p:pic>
+        <p:nvPicPr>
+          <p:cNvPr id="5" name="Image 0" descr="Samlytics Data Services">    </p:cNvPr>
+          <p:cNvPicPr>
+            <a:picLocks noChangeAspect="1"/>
+          </p:cNvPicPr>
+          <p:nvPr/>
+        </p:nvPicPr>
+        <p:blipFill>
+          <a:blip r:embed="rId1"/>
+          <a:stretch>
+            <a:fillRect/>
+          </a:stretch>
+        </p:blipFill>
+        <p:spPr>
+          <a:xfrm>
+            <a:off x="777240" y="502920"/>
+            <a:ext cx="1371600" cy="291465"/>
+          </a:xfrm>
+          <a:prstGeom prst="rect">
+            <a:avLst/>
+          </a:prstGeom>
+        </p:spPr>
+      </p:pic>
+      <p:sp>
+        <p:nvSpPr>
+          <p:cNvPr id="6" name="Text 3"/>
           <p:cNvSpPr txBox="1"/>
           <p:nvPr/>
         </p:nvSpPr>
@@ -8833,7 +9085,7 @@
       </p:sp>
       <p:sp>
         <p:nvSpPr>
-          <p:cNvPr id="5" name="Text 3"/>
+          <p:cNvPr id="7" name="Text 4"/>
           <p:cNvSpPr txBox="1"/>
           <p:nvPr/>
         </p:nvSpPr>
@@ -8872,7 +9124,7 @@
       </p:sp>
       <p:sp>
         <p:nvSpPr>
-          <p:cNvPr id="6" name="Text 4"/>
+          <p:cNvPr id="8" name="Text 5"/>
           <p:cNvSpPr txBox="1"/>
           <p:nvPr/>
         </p:nvSpPr>
@@ -8911,7 +9163,7 @@
       </p:sp>
       <p:sp>
         <p:nvSpPr>
-          <p:cNvPr id="7" name="Shape 5"/>
+          <p:cNvPr id="9" name="Shape 6"/>
           <p:cNvSpPr/>
           <p:nvPr/>
         </p:nvSpPr>
@@ -8945,14 +9197,14 @@
       </p:sp>
       <p:pic>
         <p:nvPicPr>
-          <p:cNvPr id="8" name="Image 0" descr="Attenlume screen: create conference">    </p:cNvPr>
+          <p:cNvPr id="10" name="Image 1" descr="Attenlume screen: create conference">    </p:cNvPr>
           <p:cNvPicPr>
             <a:picLocks noChangeAspect="1"/>
           </p:cNvPicPr>
           <p:nvPr/>
         </p:nvPicPr>
         <p:blipFill>
-          <a:blip r:embed="rId1"/>
+          <a:blip r:embed="rId2"/>
           <a:stretch>
             <a:fillRect/>
           </a:stretch>
@@ -9755,7 +10007,58 @@
       </p:sp>
       <p:sp>
         <p:nvSpPr>
-          <p:cNvPr id="4" name="Text 2"/>
+          <p:cNvPr id="4" name="Shape 2"/>
+          <p:cNvSpPr/>
+          <p:nvPr/>
+        </p:nvSpPr>
+        <p:spPr>
+          <a:xfrm>
+            <a:off x="685800" y="411480"/>
+            <a:ext cx="1554480" cy="474345"/>
+          </a:xfrm>
+          <a:prstGeom prst="roundRect">
+            <a:avLst>
+              <a:gd name="adj" fmla="val 15422"/>
+            </a:avLst>
+          </a:prstGeom>
+          <a:solidFill>
+            <a:srgbClr val="FEFFF8"/>
+          </a:solidFill>
+          <a:ln w="12700">
+            <a:solidFill>
+              <a:srgbClr val="FEFFF8"/>
+            </a:solidFill>
+            <a:prstDash val="solid"/>
+          </a:ln>
+        </p:spPr>
+      </p:sp>
+      <p:pic>
+        <p:nvPicPr>
+          <p:cNvPr id="5" name="Image 0" descr="Samlytics Data Services">    </p:cNvPr>
+          <p:cNvPicPr>
+            <a:picLocks noChangeAspect="1"/>
+          </p:cNvPicPr>
+          <p:nvPr/>
+        </p:nvPicPr>
+        <p:blipFill>
+          <a:blip r:embed="rId1"/>
+          <a:stretch>
+            <a:fillRect/>
+          </a:stretch>
+        </p:blipFill>
+        <p:spPr>
+          <a:xfrm>
+            <a:off x="777240" y="502920"/>
+            <a:ext cx="1371600" cy="291465"/>
+          </a:xfrm>
+          <a:prstGeom prst="rect">
+            <a:avLst/>
+          </a:prstGeom>
+        </p:spPr>
+      </p:pic>
+      <p:sp>
+        <p:nvSpPr>
+          <p:cNvPr id="6" name="Text 3"/>
           <p:cNvSpPr txBox="1"/>
           <p:nvPr/>
         </p:nvSpPr>
@@ -9794,7 +10097,7 @@
       </p:sp>
       <p:sp>
         <p:nvSpPr>
-          <p:cNvPr id="5" name="Text 3"/>
+          <p:cNvPr id="7" name="Text 4"/>
           <p:cNvSpPr txBox="1"/>
           <p:nvPr/>
         </p:nvSpPr>
@@ -9833,7 +10136,7 @@
       </p:sp>
       <p:sp>
         <p:nvSpPr>
-          <p:cNvPr id="6" name="Text 4"/>
+          <p:cNvPr id="8" name="Text 5"/>
           <p:cNvSpPr txBox="1"/>
           <p:nvPr/>
         </p:nvSpPr>
@@ -9872,7 +10175,7 @@
       </p:sp>
       <p:sp>
         <p:nvSpPr>
-          <p:cNvPr id="7" name="Shape 5"/>
+          <p:cNvPr id="9" name="Shape 6"/>
           <p:cNvSpPr/>
           <p:nvPr/>
         </p:nvSpPr>
@@ -9906,14 +10209,14 @@
       </p:sp>
       <p:pic>
         <p:nvPicPr>
-          <p:cNvPr id="8" name="Image 0" descr="Attenlume screen: recording">    </p:cNvPr>
+          <p:cNvPr id="10" name="Image 1" descr="Attenlume screen: recording">    </p:cNvPr>
           <p:cNvPicPr>
             <a:picLocks noChangeAspect="1"/>
           </p:cNvPicPr>
           <p:nvPr/>
         </p:nvPicPr>
         <p:blipFill>
-          <a:blip r:embed="rId1"/>
+          <a:blip r:embed="rId2"/>
           <a:stretch>
             <a:fillRect/>
           </a:stretch>

</xml_diff>